<commit_message>
docs: update presentation and diagrams
</commit_message>
<xml_diff>
--- a/RiskGuard_Презентация_проекта.pptx
+++ b/RiskGuard_Презентация_проекта.pptx
@@ -5,21 +5,21 @@
     <p:sldMasterId id="2147483648" r:id="rId1"/>
   </p:sldMasterIdLst>
   <p:sldIdLst>
-    <p:sldId id="256" r:id="rId7"/>
-    <p:sldId id="257" r:id="rId8"/>
-    <p:sldId id="258" r:id="rId9"/>
-    <p:sldId id="259" r:id="rId10"/>
-    <p:sldId id="260" r:id="rId11"/>
-    <p:sldId id="261" r:id="rId12"/>
-    <p:sldId id="262" r:id="rId13"/>
-    <p:sldId id="263" r:id="rId14"/>
-    <p:sldId id="264" r:id="rId15"/>
-    <p:sldId id="265" r:id="rId16"/>
-    <p:sldId id="266" r:id="rId17"/>
-    <p:sldId id="267" r:id="rId18"/>
-    <p:sldId id="268" r:id="rId19"/>
+    <p:sldId id="256" r:id="rId2"/>
+    <p:sldId id="257" r:id="rId3"/>
+    <p:sldId id="258" r:id="rId4"/>
+    <p:sldId id="259" r:id="rId5"/>
+    <p:sldId id="260" r:id="rId6"/>
+    <p:sldId id="261" r:id="rId7"/>
+    <p:sldId id="262" r:id="rId8"/>
+    <p:sldId id="263" r:id="rId9"/>
+    <p:sldId id="264" r:id="rId10"/>
+    <p:sldId id="265" r:id="rId11"/>
+    <p:sldId id="266" r:id="rId12"/>
+    <p:sldId id="267" r:id="rId13"/>
+    <p:sldId id="268" r:id="rId14"/>
   </p:sldIdLst>
-  <p:sldSz cx="12191695" cy="6858000" type="screen4x3"/>
+  <p:sldSz cx="12192000" cy="6858000"/>
   <p:notesSz cx="6858000" cy="9144000"/>
   <p:defaultTextStyle>
     <a:defPPr>
@@ -116,6 +116,22 @@
       </a:defRPr>
     </a:lvl9pPr>
   </p:defaultTextStyle>
+  <p:extLst>
+    <p:ext uri="{EFAFB233-063F-42B5-8137-9DF3F51BA10A}">
+      <p15:sldGuideLst xmlns:p15="http://schemas.microsoft.com/office/powerpoint/2012/main">
+        <p15:guide id="1" orient="horz" pos="2160">
+          <p15:clr>
+            <a:srgbClr val="A4A3A4"/>
+          </p15:clr>
+        </p15:guide>
+        <p15:guide id="2" pos="2880">
+          <p15:clr>
+            <a:srgbClr val="A4A3A4"/>
+          </p15:clr>
+        </p15:guide>
+      </p15:sldGuideLst>
+    </p:ext>
+  </p:extLst>
 </p:presentation>
 </file>
 
@@ -157,10 +173,9 @@
           <a:lstStyle/>
           <a:p>
             <a:r>
-              <a:rPr lang="en-US" smtClean="0"/>
+              <a:rPr lang="en-US"/>
               <a:t>Click to edit Master title style</a:t>
             </a:r>
-            <a:endParaRPr lang="en-US"/>
           </a:p>
         </p:txBody>
       </p:sp>
@@ -276,10 +291,9 @@
           </a:lstStyle>
           <a:p>
             <a:r>
-              <a:rPr lang="en-US" smtClean="0"/>
+              <a:rPr lang="en-US"/>
               <a:t>Click to edit Master subtitle style</a:t>
             </a:r>
-            <a:endParaRPr lang="en-US"/>
           </a:p>
         </p:txBody>
       </p:sp>
@@ -300,7 +314,7 @@
           <a:p>
             <a:fld id="{5BCAD085-E8A6-8845-BD4E-CB4CCA059FC4}" type="datetimeFigureOut">
               <a:rPr lang="en-US" smtClean="0"/>
-              <a:t>1/27/13</a:t>
+              <a:t>5/5/2026</a:t>
             </a:fld>
             <a:endParaRPr lang="en-US"/>
           </a:p>
@@ -394,10 +408,9 @@
           <a:lstStyle/>
           <a:p>
             <a:r>
-              <a:rPr lang="en-US" smtClean="0"/>
+              <a:rPr lang="en-US"/>
               <a:t>Click to edit Master title style</a:t>
             </a:r>
-            <a:endParaRPr lang="en-US"/>
           </a:p>
         </p:txBody>
       </p:sp>
@@ -418,38 +431,37 @@
           <a:p>
             <a:pPr lvl="0"/>
             <a:r>
-              <a:rPr lang="en-US" smtClean="0"/>
+              <a:rPr lang="en-US"/>
               <a:t>Click to edit Master text styles</a:t>
             </a:r>
           </a:p>
           <a:p>
             <a:pPr lvl="1"/>
             <a:r>
-              <a:rPr lang="en-US" smtClean="0"/>
+              <a:rPr lang="en-US"/>
               <a:t>Second level</a:t>
             </a:r>
           </a:p>
           <a:p>
             <a:pPr lvl="2"/>
             <a:r>
-              <a:rPr lang="en-US" smtClean="0"/>
+              <a:rPr lang="en-US"/>
               <a:t>Third level</a:t>
             </a:r>
           </a:p>
           <a:p>
             <a:pPr lvl="3"/>
             <a:r>
-              <a:rPr lang="en-US" smtClean="0"/>
+              <a:rPr lang="en-US"/>
               <a:t>Fourth level</a:t>
             </a:r>
           </a:p>
           <a:p>
             <a:pPr lvl="4"/>
             <a:r>
-              <a:rPr lang="en-US" smtClean="0"/>
+              <a:rPr lang="en-US"/>
               <a:t>Fifth level</a:t>
             </a:r>
-            <a:endParaRPr lang="en-US"/>
           </a:p>
         </p:txBody>
       </p:sp>
@@ -470,7 +482,7 @@
           <a:p>
             <a:fld id="{5BCAD085-E8A6-8845-BD4E-CB4CCA059FC4}" type="datetimeFigureOut">
               <a:rPr lang="en-US" smtClean="0"/>
-              <a:t>1/27/13</a:t>
+              <a:t>5/5/2026</a:t>
             </a:fld>
             <a:endParaRPr lang="en-US"/>
           </a:p>
@@ -569,10 +581,9 @@
           <a:lstStyle/>
           <a:p>
             <a:r>
-              <a:rPr lang="en-US" smtClean="0"/>
+              <a:rPr lang="en-US"/>
               <a:t>Click to edit Master title style</a:t>
             </a:r>
-            <a:endParaRPr lang="en-US"/>
           </a:p>
         </p:txBody>
       </p:sp>
@@ -598,38 +609,37 @@
           <a:p>
             <a:pPr lvl="0"/>
             <a:r>
-              <a:rPr lang="en-US" smtClean="0"/>
+              <a:rPr lang="en-US"/>
               <a:t>Click to edit Master text styles</a:t>
             </a:r>
           </a:p>
           <a:p>
             <a:pPr lvl="1"/>
             <a:r>
-              <a:rPr lang="en-US" smtClean="0"/>
+              <a:rPr lang="en-US"/>
               <a:t>Second level</a:t>
             </a:r>
           </a:p>
           <a:p>
             <a:pPr lvl="2"/>
             <a:r>
-              <a:rPr lang="en-US" smtClean="0"/>
+              <a:rPr lang="en-US"/>
               <a:t>Third level</a:t>
             </a:r>
           </a:p>
           <a:p>
             <a:pPr lvl="3"/>
             <a:r>
-              <a:rPr lang="en-US" smtClean="0"/>
+              <a:rPr lang="en-US"/>
               <a:t>Fourth level</a:t>
             </a:r>
           </a:p>
           <a:p>
             <a:pPr lvl="4"/>
             <a:r>
-              <a:rPr lang="en-US" smtClean="0"/>
+              <a:rPr lang="en-US"/>
               <a:t>Fifth level</a:t>
             </a:r>
-            <a:endParaRPr lang="en-US"/>
           </a:p>
         </p:txBody>
       </p:sp>
@@ -650,7 +660,7 @@
           <a:p>
             <a:fld id="{5BCAD085-E8A6-8845-BD4E-CB4CCA059FC4}" type="datetimeFigureOut">
               <a:rPr lang="en-US" smtClean="0"/>
-              <a:t>1/27/13</a:t>
+              <a:t>5/5/2026</a:t>
             </a:fld>
             <a:endParaRPr lang="en-US"/>
           </a:p>
@@ -744,10 +754,9 @@
           <a:lstStyle/>
           <a:p>
             <a:r>
-              <a:rPr lang="en-US" smtClean="0"/>
+              <a:rPr lang="en-US"/>
               <a:t>Click to edit Master title style</a:t>
             </a:r>
-            <a:endParaRPr lang="en-US"/>
           </a:p>
         </p:txBody>
       </p:sp>
@@ -768,38 +777,37 @@
           <a:p>
             <a:pPr lvl="0"/>
             <a:r>
-              <a:rPr lang="en-US" smtClean="0"/>
+              <a:rPr lang="en-US"/>
               <a:t>Click to edit Master text styles</a:t>
             </a:r>
           </a:p>
           <a:p>
             <a:pPr lvl="1"/>
             <a:r>
-              <a:rPr lang="en-US" smtClean="0"/>
+              <a:rPr lang="en-US"/>
               <a:t>Second level</a:t>
             </a:r>
           </a:p>
           <a:p>
             <a:pPr lvl="2"/>
             <a:r>
-              <a:rPr lang="en-US" smtClean="0"/>
+              <a:rPr lang="en-US"/>
               <a:t>Third level</a:t>
             </a:r>
           </a:p>
           <a:p>
             <a:pPr lvl="3"/>
             <a:r>
-              <a:rPr lang="en-US" smtClean="0"/>
+              <a:rPr lang="en-US"/>
               <a:t>Fourth level</a:t>
             </a:r>
           </a:p>
           <a:p>
             <a:pPr lvl="4"/>
             <a:r>
-              <a:rPr lang="en-US" smtClean="0"/>
+              <a:rPr lang="en-US"/>
               <a:t>Fifth level</a:t>
             </a:r>
-            <a:endParaRPr lang="en-US"/>
           </a:p>
         </p:txBody>
       </p:sp>
@@ -820,7 +828,7 @@
           <a:p>
             <a:fld id="{5BCAD085-E8A6-8845-BD4E-CB4CCA059FC4}" type="datetimeFigureOut">
               <a:rPr lang="en-US" smtClean="0"/>
-              <a:t>1/27/13</a:t>
+              <a:t>5/5/2026</a:t>
             </a:fld>
             <a:endParaRPr lang="en-US"/>
           </a:p>
@@ -923,10 +931,9 @@
           </a:lstStyle>
           <a:p>
             <a:r>
-              <a:rPr lang="en-US" smtClean="0"/>
+              <a:rPr lang="en-US"/>
               <a:t>Click to edit Master title style</a:t>
             </a:r>
-            <a:endParaRPr lang="en-US"/>
           </a:p>
         </p:txBody>
       </p:sp>
@@ -1043,7 +1050,7 @@
           <a:p>
             <a:pPr lvl="0"/>
             <a:r>
-              <a:rPr lang="en-US" smtClean="0"/>
+              <a:rPr lang="en-US"/>
               <a:t>Click to edit Master text styles</a:t>
             </a:r>
           </a:p>
@@ -1066,7 +1073,7 @@
           <a:p>
             <a:fld id="{5BCAD085-E8A6-8845-BD4E-CB4CCA059FC4}" type="datetimeFigureOut">
               <a:rPr lang="en-US" smtClean="0"/>
-              <a:t>1/27/13</a:t>
+              <a:t>5/5/2026</a:t>
             </a:fld>
             <a:endParaRPr lang="en-US"/>
           </a:p>
@@ -1160,10 +1167,9 @@
           <a:lstStyle/>
           <a:p>
             <a:r>
-              <a:rPr lang="en-US" smtClean="0"/>
+              <a:rPr lang="en-US"/>
               <a:t>Click to edit Master title style</a:t>
             </a:r>
-            <a:endParaRPr lang="en-US"/>
           </a:p>
         </p:txBody>
       </p:sp>
@@ -1217,38 +1223,37 @@
           <a:p>
             <a:pPr lvl="0"/>
             <a:r>
-              <a:rPr lang="en-US" smtClean="0"/>
+              <a:rPr lang="en-US"/>
               <a:t>Click to edit Master text styles</a:t>
             </a:r>
           </a:p>
           <a:p>
             <a:pPr lvl="1"/>
             <a:r>
-              <a:rPr lang="en-US" smtClean="0"/>
+              <a:rPr lang="en-US"/>
               <a:t>Second level</a:t>
             </a:r>
           </a:p>
           <a:p>
             <a:pPr lvl="2"/>
             <a:r>
-              <a:rPr lang="en-US" smtClean="0"/>
+              <a:rPr lang="en-US"/>
               <a:t>Third level</a:t>
             </a:r>
           </a:p>
           <a:p>
             <a:pPr lvl="3"/>
             <a:r>
-              <a:rPr lang="en-US" smtClean="0"/>
+              <a:rPr lang="en-US"/>
               <a:t>Fourth level</a:t>
             </a:r>
           </a:p>
           <a:p>
             <a:pPr lvl="4"/>
             <a:r>
-              <a:rPr lang="en-US" smtClean="0"/>
+              <a:rPr lang="en-US"/>
               <a:t>Fifth level</a:t>
             </a:r>
-            <a:endParaRPr lang="en-US"/>
           </a:p>
         </p:txBody>
       </p:sp>
@@ -1302,38 +1307,37 @@
           <a:p>
             <a:pPr lvl="0"/>
             <a:r>
-              <a:rPr lang="en-US" smtClean="0"/>
+              <a:rPr lang="en-US"/>
               <a:t>Click to edit Master text styles</a:t>
             </a:r>
           </a:p>
           <a:p>
             <a:pPr lvl="1"/>
             <a:r>
-              <a:rPr lang="en-US" smtClean="0"/>
+              <a:rPr lang="en-US"/>
               <a:t>Second level</a:t>
             </a:r>
           </a:p>
           <a:p>
             <a:pPr lvl="2"/>
             <a:r>
-              <a:rPr lang="en-US" smtClean="0"/>
+              <a:rPr lang="en-US"/>
               <a:t>Third level</a:t>
             </a:r>
           </a:p>
           <a:p>
             <a:pPr lvl="3"/>
             <a:r>
-              <a:rPr lang="en-US" smtClean="0"/>
+              <a:rPr lang="en-US"/>
               <a:t>Fourth level</a:t>
             </a:r>
           </a:p>
           <a:p>
             <a:pPr lvl="4"/>
             <a:r>
-              <a:rPr lang="en-US" smtClean="0"/>
+              <a:rPr lang="en-US"/>
               <a:t>Fifth level</a:t>
             </a:r>
-            <a:endParaRPr lang="en-US"/>
           </a:p>
         </p:txBody>
       </p:sp>
@@ -1354,7 +1358,7 @@
           <a:p>
             <a:fld id="{5BCAD085-E8A6-8845-BD4E-CB4CCA059FC4}" type="datetimeFigureOut">
               <a:rPr lang="en-US" smtClean="0"/>
-              <a:t>1/27/13</a:t>
+              <a:t>5/5/2026</a:t>
             </a:fld>
             <a:endParaRPr lang="en-US"/>
           </a:p>
@@ -1452,10 +1456,9 @@
           </a:lstStyle>
           <a:p>
             <a:r>
-              <a:rPr lang="en-US" smtClean="0"/>
+              <a:rPr lang="en-US"/>
               <a:t>Click to edit Master title style</a:t>
             </a:r>
-            <a:endParaRPr lang="en-US"/>
           </a:p>
         </p:txBody>
       </p:sp>
@@ -1518,7 +1521,7 @@
           <a:p>
             <a:pPr lvl="0"/>
             <a:r>
-              <a:rPr lang="en-US" smtClean="0"/>
+              <a:rPr lang="en-US"/>
               <a:t>Click to edit Master text styles</a:t>
             </a:r>
           </a:p>
@@ -1574,38 +1577,37 @@
           <a:p>
             <a:pPr lvl="0"/>
             <a:r>
-              <a:rPr lang="en-US" smtClean="0"/>
+              <a:rPr lang="en-US"/>
               <a:t>Click to edit Master text styles</a:t>
             </a:r>
           </a:p>
           <a:p>
             <a:pPr lvl="1"/>
             <a:r>
-              <a:rPr lang="en-US" smtClean="0"/>
+              <a:rPr lang="en-US"/>
               <a:t>Second level</a:t>
             </a:r>
           </a:p>
           <a:p>
             <a:pPr lvl="2"/>
             <a:r>
-              <a:rPr lang="en-US" smtClean="0"/>
+              <a:rPr lang="en-US"/>
               <a:t>Third level</a:t>
             </a:r>
           </a:p>
           <a:p>
             <a:pPr lvl="3"/>
             <a:r>
-              <a:rPr lang="en-US" smtClean="0"/>
+              <a:rPr lang="en-US"/>
               <a:t>Fourth level</a:t>
             </a:r>
           </a:p>
           <a:p>
             <a:pPr lvl="4"/>
             <a:r>
-              <a:rPr lang="en-US" smtClean="0"/>
+              <a:rPr lang="en-US"/>
               <a:t>Fifth level</a:t>
             </a:r>
-            <a:endParaRPr lang="en-US"/>
           </a:p>
         </p:txBody>
       </p:sp>
@@ -1668,7 +1670,7 @@
           <a:p>
             <a:pPr lvl="0"/>
             <a:r>
-              <a:rPr lang="en-US" smtClean="0"/>
+              <a:rPr lang="en-US"/>
               <a:t>Click to edit Master text styles</a:t>
             </a:r>
           </a:p>
@@ -1724,38 +1726,37 @@
           <a:p>
             <a:pPr lvl="0"/>
             <a:r>
-              <a:rPr lang="en-US" smtClean="0"/>
+              <a:rPr lang="en-US"/>
               <a:t>Click to edit Master text styles</a:t>
             </a:r>
           </a:p>
           <a:p>
             <a:pPr lvl="1"/>
             <a:r>
-              <a:rPr lang="en-US" smtClean="0"/>
+              <a:rPr lang="en-US"/>
               <a:t>Second level</a:t>
             </a:r>
           </a:p>
           <a:p>
             <a:pPr lvl="2"/>
             <a:r>
-              <a:rPr lang="en-US" smtClean="0"/>
+              <a:rPr lang="en-US"/>
               <a:t>Third level</a:t>
             </a:r>
           </a:p>
           <a:p>
             <a:pPr lvl="3"/>
             <a:r>
-              <a:rPr lang="en-US" smtClean="0"/>
+              <a:rPr lang="en-US"/>
               <a:t>Fourth level</a:t>
             </a:r>
           </a:p>
           <a:p>
             <a:pPr lvl="4"/>
             <a:r>
-              <a:rPr lang="en-US" smtClean="0"/>
+              <a:rPr lang="en-US"/>
               <a:t>Fifth level</a:t>
             </a:r>
-            <a:endParaRPr lang="en-US"/>
           </a:p>
         </p:txBody>
       </p:sp>
@@ -1776,7 +1777,7 @@
           <a:p>
             <a:fld id="{5BCAD085-E8A6-8845-BD4E-CB4CCA059FC4}" type="datetimeFigureOut">
               <a:rPr lang="en-US" smtClean="0"/>
-              <a:t>1/27/13</a:t>
+              <a:t>5/5/2026</a:t>
             </a:fld>
             <a:endParaRPr lang="en-US"/>
           </a:p>
@@ -1870,10 +1871,9 @@
           <a:lstStyle/>
           <a:p>
             <a:r>
-              <a:rPr lang="en-US" smtClean="0"/>
+              <a:rPr lang="en-US"/>
               <a:t>Click to edit Master title style</a:t>
             </a:r>
-            <a:endParaRPr lang="en-US"/>
           </a:p>
         </p:txBody>
       </p:sp>
@@ -1894,7 +1894,7 @@
           <a:p>
             <a:fld id="{5BCAD085-E8A6-8845-BD4E-CB4CCA059FC4}" type="datetimeFigureOut">
               <a:rPr lang="en-US" smtClean="0"/>
-              <a:t>1/27/13</a:t>
+              <a:t>5/5/2026</a:t>
             </a:fld>
             <a:endParaRPr lang="en-US"/>
           </a:p>
@@ -1989,7 +1989,7 @@
           <a:p>
             <a:fld id="{5BCAD085-E8A6-8845-BD4E-CB4CCA059FC4}" type="datetimeFigureOut">
               <a:rPr lang="en-US" smtClean="0"/>
-              <a:t>1/27/13</a:t>
+              <a:t>5/5/2026</a:t>
             </a:fld>
             <a:endParaRPr lang="en-US"/>
           </a:p>
@@ -2092,10 +2092,9 @@
           </a:lstStyle>
           <a:p>
             <a:r>
-              <a:rPr lang="en-US" smtClean="0"/>
+              <a:rPr lang="en-US"/>
               <a:t>Click to edit Master title style</a:t>
             </a:r>
-            <a:endParaRPr lang="en-US"/>
           </a:p>
         </p:txBody>
       </p:sp>
@@ -2149,38 +2148,37 @@
           <a:p>
             <a:pPr lvl="0"/>
             <a:r>
-              <a:rPr lang="en-US" smtClean="0"/>
+              <a:rPr lang="en-US"/>
               <a:t>Click to edit Master text styles</a:t>
             </a:r>
           </a:p>
           <a:p>
             <a:pPr lvl="1"/>
             <a:r>
-              <a:rPr lang="en-US" smtClean="0"/>
+              <a:rPr lang="en-US"/>
               <a:t>Second level</a:t>
             </a:r>
           </a:p>
           <a:p>
             <a:pPr lvl="2"/>
             <a:r>
-              <a:rPr lang="en-US" smtClean="0"/>
+              <a:rPr lang="en-US"/>
               <a:t>Third level</a:t>
             </a:r>
           </a:p>
           <a:p>
             <a:pPr lvl="3"/>
             <a:r>
-              <a:rPr lang="en-US" smtClean="0"/>
+              <a:rPr lang="en-US"/>
               <a:t>Fourth level</a:t>
             </a:r>
           </a:p>
           <a:p>
             <a:pPr lvl="4"/>
             <a:r>
-              <a:rPr lang="en-US" smtClean="0"/>
+              <a:rPr lang="en-US"/>
               <a:t>Fifth level</a:t>
             </a:r>
-            <a:endParaRPr lang="en-US"/>
           </a:p>
         </p:txBody>
       </p:sp>
@@ -2243,7 +2241,7 @@
           <a:p>
             <a:pPr lvl="0"/>
             <a:r>
-              <a:rPr lang="en-US" smtClean="0"/>
+              <a:rPr lang="en-US"/>
               <a:t>Click to edit Master text styles</a:t>
             </a:r>
           </a:p>
@@ -2266,7 +2264,7 @@
           <a:p>
             <a:fld id="{5BCAD085-E8A6-8845-BD4E-CB4CCA059FC4}" type="datetimeFigureOut">
               <a:rPr lang="en-US" smtClean="0"/>
-              <a:t>1/27/13</a:t>
+              <a:t>5/5/2026</a:t>
             </a:fld>
             <a:endParaRPr lang="en-US"/>
           </a:p>
@@ -2369,10 +2367,9 @@
           </a:lstStyle>
           <a:p>
             <a:r>
-              <a:rPr lang="en-US" smtClean="0"/>
+              <a:rPr lang="en-US"/>
               <a:t>Click to edit Master title style</a:t>
             </a:r>
-            <a:endParaRPr lang="en-US"/>
           </a:p>
         </p:txBody>
       </p:sp>
@@ -2496,7 +2493,7 @@
           <a:p>
             <a:pPr lvl="0"/>
             <a:r>
-              <a:rPr lang="en-US" smtClean="0"/>
+              <a:rPr lang="en-US"/>
               <a:t>Click to edit Master text styles</a:t>
             </a:r>
           </a:p>
@@ -2519,7 +2516,7 @@
           <a:p>
             <a:fld id="{5BCAD085-E8A6-8845-BD4E-CB4CCA059FC4}" type="datetimeFigureOut">
               <a:rPr lang="en-US" smtClean="0"/>
-              <a:t>1/27/13</a:t>
+              <a:t>5/5/2026</a:t>
             </a:fld>
             <a:endParaRPr lang="en-US"/>
           </a:p>
@@ -2628,10 +2625,9 @@
           <a:lstStyle/>
           <a:p>
             <a:r>
-              <a:rPr lang="en-US" smtClean="0"/>
+              <a:rPr lang="en-US"/>
               <a:t>Click to edit Master title style</a:t>
             </a:r>
-            <a:endParaRPr lang="en-US"/>
           </a:p>
         </p:txBody>
       </p:sp>
@@ -2662,38 +2658,37 @@
           <a:p>
             <a:pPr lvl="0"/>
             <a:r>
-              <a:rPr lang="en-US" smtClean="0"/>
+              <a:rPr lang="en-US"/>
               <a:t>Click to edit Master text styles</a:t>
             </a:r>
           </a:p>
           <a:p>
             <a:pPr lvl="1"/>
             <a:r>
-              <a:rPr lang="en-US" smtClean="0"/>
+              <a:rPr lang="en-US"/>
               <a:t>Second level</a:t>
             </a:r>
           </a:p>
           <a:p>
             <a:pPr lvl="2"/>
             <a:r>
-              <a:rPr lang="en-US" smtClean="0"/>
+              <a:rPr lang="en-US"/>
               <a:t>Third level</a:t>
             </a:r>
           </a:p>
           <a:p>
             <a:pPr lvl="3"/>
             <a:r>
-              <a:rPr lang="en-US" smtClean="0"/>
+              <a:rPr lang="en-US"/>
               <a:t>Fourth level</a:t>
             </a:r>
           </a:p>
           <a:p>
             <a:pPr lvl="4"/>
             <a:r>
-              <a:rPr lang="en-US" smtClean="0"/>
+              <a:rPr lang="en-US"/>
               <a:t>Fifth level</a:t>
             </a:r>
-            <a:endParaRPr lang="en-US"/>
           </a:p>
         </p:txBody>
       </p:sp>
@@ -2732,7 +2727,7 @@
           <a:p>
             <a:fld id="{5BCAD085-E8A6-8845-BD4E-CB4CCA059FC4}" type="datetimeFigureOut">
               <a:rPr lang="en-US" smtClean="0"/>
-              <a:t>1/27/13</a:t>
+              <a:t>5/5/2026</a:t>
             </a:fld>
             <a:endParaRPr lang="en-US"/>
           </a:p>
@@ -3091,7 +3086,7 @@
 </file>
 
 <file path=ppt/slides/slide1.xml><?xml version="1.0" encoding="utf-8"?>
-<p:sld xmlns:a="http://schemas.openxmlformats.org/drawingml/2006/main" xmlns:p="http://schemas.openxmlformats.org/presentationml/2006/main" xmlns:r="http://schemas.openxmlformats.org/officeDocument/2006/relationships">
+<p:sld xmlns:a="http://schemas.openxmlformats.org/drawingml/2006/main" xmlns:r="http://schemas.openxmlformats.org/officeDocument/2006/relationships" xmlns:p="http://schemas.openxmlformats.org/presentationml/2006/main">
   <p:cSld>
     <p:bg>
       <p:bgPr>
@@ -3107,7 +3102,14 @@
         <p:cNvGrpSpPr/>
         <p:nvPr/>
       </p:nvGrpSpPr>
-      <p:grpSpPr/>
+      <p:grpSpPr>
+        <a:xfrm>
+          <a:off x="0" y="0"/>
+          <a:ext cx="0" cy="0"/>
+          <a:chOff x="0" y="0"/>
+          <a:chExt cx="0" cy="0"/>
+        </a:xfrm>
+      </p:grpSpPr>
       <p:sp>
         <p:nvSpPr>
           <p:cNvPr id="2" name="TextBox 1"/>
@@ -3131,7 +3133,7 @@
           <a:lstStyle/>
           <a:p>
             <a:pPr>
-              <a:defRPr b="1" sz="2800">
+              <a:defRPr sz="2800" b="1">
                 <a:solidFill>
                   <a:srgbClr val="121F36"/>
                 </a:solidFill>
@@ -3229,8 +3231,8 @@
         </p:blipFill>
         <p:spPr>
           <a:xfrm>
-            <a:off x="8732520" y="1234440"/>
-            <a:ext cx="1828800" cy="2743200"/>
+            <a:off x="7064246" y="1032254"/>
+            <a:ext cx="3256621" cy="4884932"/>
           </a:xfrm>
           <a:prstGeom prst="rect">
             <a:avLst/>
@@ -3316,64 +3318,6 @@
             </a:pPr>
             <a:r>
               <a:t>Единый Flask API и общая база</a:t>
-            </a:r>
-          </a:p>
-        </p:txBody>
-      </p:sp>
-      <p:sp>
-        <p:nvSpPr>
-          <p:cNvPr id="7" name="Rounded Rectangle 6"/>
-          <p:cNvSpPr/>
-          <p:nvPr/>
-        </p:nvSpPr>
-        <p:spPr>
-          <a:xfrm>
-            <a:off x="6400800" y="3749039"/>
-            <a:ext cx="4572000" cy="1280160"/>
-          </a:xfrm>
-          <a:prstGeom prst="roundRect">
-            <a:avLst/>
-          </a:prstGeom>
-          <a:solidFill>
-            <a:srgbClr val="FFFFFF"/>
-          </a:solidFill>
-          <a:ln w="15240">
-            <a:solidFill>
-              <a:srgbClr val="C7D5EB"/>
-            </a:solidFill>
-          </a:ln>
-        </p:spPr>
-        <p:style>
-          <a:lnRef idx="1">
-            <a:schemeClr val="accent1"/>
-          </a:lnRef>
-          <a:fillRef idx="3">
-            <a:schemeClr val="accent1"/>
-          </a:fillRef>
-          <a:effectRef idx="2">
-            <a:schemeClr val="accent1"/>
-          </a:effectRef>
-          <a:fontRef idx="minor">
-            <a:schemeClr val="lt1"/>
-          </a:fontRef>
-        </p:style>
-        <p:txBody>
-          <a:bodyPr rtlCol="0" anchor="ctr"/>
-          <a:lstStyle/>
-          <a:p>
-            <a:pPr algn="ctr">
-              <a:defRPr sz="1800" b="1">
-                <a:solidFill>
-                  <a:srgbClr val="607496"/>
-                </a:solidFill>
-              </a:defRPr>
-            </a:pPr>
-            <a:r>
-              <a:t>Скриншот по желанию:</a:t>
-            </a:r>
-            <a:br/>
-            <a:r>
-              <a:t>титульный экран или логотип</a:t>
             </a:r>
           </a:p>
         </p:txBody>
@@ -3387,7 +3331,7 @@
 </file>
 
 <file path=ppt/slides/slide10.xml><?xml version="1.0" encoding="utf-8"?>
-<p:sld xmlns:a="http://schemas.openxmlformats.org/drawingml/2006/main" xmlns:p="http://schemas.openxmlformats.org/presentationml/2006/main" xmlns:r="http://schemas.openxmlformats.org/officeDocument/2006/relationships">
+<p:sld xmlns:a="http://schemas.openxmlformats.org/drawingml/2006/main" xmlns:r="http://schemas.openxmlformats.org/officeDocument/2006/relationships" xmlns:p="http://schemas.openxmlformats.org/presentationml/2006/main">
   <p:cSld>
     <p:bg>
       <p:bgPr>
@@ -3403,7 +3347,14 @@
         <p:cNvGrpSpPr/>
         <p:nvPr/>
       </p:nvGrpSpPr>
-      <p:grpSpPr/>
+      <p:grpSpPr>
+        <a:xfrm>
+          <a:off x="0" y="0"/>
+          <a:ext cx="0" cy="0"/>
+          <a:chOff x="0" y="0"/>
+          <a:chExt cx="0" cy="0"/>
+        </a:xfrm>
+      </p:grpSpPr>
       <p:sp>
         <p:nvSpPr>
           <p:cNvPr id="2" name="TextBox 1"/>
@@ -3427,7 +3378,7 @@
           <a:lstStyle/>
           <a:p>
             <a:pPr>
-              <a:defRPr b="1" sz="2800">
+              <a:defRPr sz="2800" b="1">
                 <a:solidFill>
                   <a:srgbClr val="121F36"/>
                 </a:solidFill>
@@ -3517,7 +3468,7 @@
         </p:nvSpPr>
         <p:spPr>
           <a:xfrm>
-            <a:off x="685800" y="1417320"/>
+            <a:off x="270933" y="1366667"/>
             <a:ext cx="5303520" cy="4114800"/>
           </a:xfrm>
           <a:prstGeom prst="rect">
@@ -3542,8 +3493,26 @@
               </a:defRPr>
             </a:pPr>
             <a:r>
-              <a:t>Очередь событий domain_event</a:t>
-            </a:r>
+              <a:rPr dirty="0" err="1"/>
+              <a:t>Очередь</a:t>
+            </a:r>
+            <a:r>
+              <a:rPr dirty="0"/>
+              <a:t> </a:t>
+            </a:r>
+            <a:r>
+              <a:rPr dirty="0" err="1"/>
+              <a:t>событий</a:t>
+            </a:r>
+            <a:r>
+              <a:rPr dirty="0"/>
+              <a:t> </a:t>
+            </a:r>
+            <a:r>
+              <a:rPr dirty="0" err="1"/>
+              <a:t>domain_event</a:t>
+            </a:r>
+            <a:endParaRPr dirty="0"/>
           </a:p>
           <a:p>
             <a:pPr>
@@ -3557,7 +3526,12 @@
               </a:defRPr>
             </a:pPr>
             <a:r>
-              <a:t>Обновление read-model</a:t>
+              <a:rPr dirty="0" err="1"/>
+              <a:t>Обновление</a:t>
+            </a:r>
+            <a:r>
+              <a:rPr dirty="0"/>
+              <a:t> read-model</a:t>
             </a:r>
           </a:p>
           <a:p>
@@ -3572,8 +3546,26 @@
               </a:defRPr>
             </a:pPr>
             <a:r>
-              <a:t>Журнал аудита действий</a:t>
-            </a:r>
+              <a:rPr dirty="0" err="1"/>
+              <a:t>Журнал</a:t>
+            </a:r>
+            <a:r>
+              <a:rPr dirty="0"/>
+              <a:t> </a:t>
+            </a:r>
+            <a:r>
+              <a:rPr dirty="0" err="1"/>
+              <a:t>аудита</a:t>
+            </a:r>
+            <a:r>
+              <a:rPr dirty="0"/>
+              <a:t> </a:t>
+            </a:r>
+            <a:r>
+              <a:rPr dirty="0" err="1"/>
+              <a:t>действий</a:t>
+            </a:r>
+            <a:endParaRPr dirty="0"/>
           </a:p>
           <a:p>
             <a:pPr>
@@ -3587,69 +3579,101 @@
               </a:defRPr>
             </a:pPr>
             <a:r>
-              <a:t>Heatmap API для частых и тяжелых запросов</a:t>
-            </a:r>
-          </a:p>
-        </p:txBody>
-      </p:sp>
-      <p:sp>
-        <p:nvSpPr>
-          <p:cNvPr id="6" name="Rounded Rectangle 5"/>
-          <p:cNvSpPr/>
+              <a:rPr dirty="0"/>
+              <a:t>Heatmap API </a:t>
+            </a:r>
+            <a:r>
+              <a:rPr dirty="0" err="1"/>
+              <a:t>для</a:t>
+            </a:r>
+            <a:r>
+              <a:rPr dirty="0"/>
+              <a:t> </a:t>
+            </a:r>
+            <a:r>
+              <a:rPr dirty="0" err="1"/>
+              <a:t>частых</a:t>
+            </a:r>
+            <a:r>
+              <a:rPr dirty="0"/>
+              <a:t> и </a:t>
+            </a:r>
+            <a:r>
+              <a:rPr dirty="0" err="1"/>
+              <a:t>тяжелых</a:t>
+            </a:r>
+            <a:r>
+              <a:rPr dirty="0"/>
+              <a:t> </a:t>
+            </a:r>
+            <a:r>
+              <a:rPr dirty="0" err="1"/>
+              <a:t>запросов</a:t>
+            </a:r>
+            <a:endParaRPr dirty="0"/>
+          </a:p>
+        </p:txBody>
+      </p:sp>
+      <p:pic>
+        <p:nvPicPr>
+          <p:cNvPr id="8" name="Рисунок 7">
+            <a:extLst>
+              <a:ext uri="{FF2B5EF4-FFF2-40B4-BE49-F238E27FC236}">
+                <a16:creationId xmlns:a16="http://schemas.microsoft.com/office/drawing/2014/main" id="{38B8D507-3A74-469B-87D2-029B6A6EE95A}"/>
+              </a:ext>
+            </a:extLst>
+          </p:cNvPr>
+          <p:cNvPicPr>
+            <a:picLocks noChangeAspect="1"/>
+          </p:cNvPicPr>
           <p:nvPr/>
-        </p:nvSpPr>
-        <p:spPr>
-          <a:xfrm>
-            <a:off x="6263640" y="1325880"/>
-            <a:ext cx="5212080" cy="4480560"/>
-          </a:xfrm>
-          <a:prstGeom prst="roundRect">
+        </p:nvPicPr>
+        <p:blipFill>
+          <a:blip r:embed="rId2"/>
+          <a:stretch>
+            <a:fillRect/>
+          </a:stretch>
+        </p:blipFill>
+        <p:spPr>
+          <a:xfrm>
+            <a:off x="4797178" y="0"/>
+            <a:ext cx="7394822" cy="2699469"/>
+          </a:xfrm>
+          <a:prstGeom prst="rect">
             <a:avLst/>
           </a:prstGeom>
-          <a:solidFill>
-            <a:srgbClr val="FFFFFF"/>
-          </a:solidFill>
-          <a:ln w="15240">
-            <a:solidFill>
-              <a:srgbClr val="C7D5EB"/>
-            </a:solidFill>
-          </a:ln>
-        </p:spPr>
-        <p:style>
-          <a:lnRef idx="1">
-            <a:schemeClr val="accent1"/>
-          </a:lnRef>
-          <a:fillRef idx="3">
-            <a:schemeClr val="accent1"/>
-          </a:fillRef>
-          <a:effectRef idx="2">
-            <a:schemeClr val="accent1"/>
-          </a:effectRef>
-          <a:fontRef idx="minor">
-            <a:schemeClr val="lt1"/>
-          </a:fontRef>
-        </p:style>
-        <p:txBody>
-          <a:bodyPr rtlCol="0" anchor="ctr"/>
-          <a:lstStyle/>
-          <a:p>
-            <a:pPr algn="ctr">
-              <a:defRPr sz="1800" b="1">
-                <a:solidFill>
-                  <a:srgbClr val="607496"/>
-                </a:solidFill>
-              </a:defRPr>
-            </a:pPr>
-            <a:r>
-              <a:t>Скриншот:</a:t>
-            </a:r>
-            <a:br/>
-            <a:r>
-              <a:t>фоновые задачи или журнал аудита</a:t>
-            </a:r>
-          </a:p>
-        </p:txBody>
-      </p:sp>
+        </p:spPr>
+      </p:pic>
+      <p:pic>
+        <p:nvPicPr>
+          <p:cNvPr id="10" name="Рисунок 9">
+            <a:extLst>
+              <a:ext uri="{FF2B5EF4-FFF2-40B4-BE49-F238E27FC236}">
+                <a16:creationId xmlns:a16="http://schemas.microsoft.com/office/drawing/2014/main" id="{B9CDA755-4204-4B4E-A0E2-67E7909A53C4}"/>
+              </a:ext>
+            </a:extLst>
+          </p:cNvPr>
+          <p:cNvPicPr>
+            <a:picLocks noChangeAspect="1"/>
+          </p:cNvPicPr>
+          <p:nvPr/>
+        </p:nvPicPr>
+        <p:blipFill>
+          <a:blip r:embed="rId3"/>
+          <a:stretch>
+            <a:fillRect/>
+          </a:stretch>
+        </p:blipFill>
+        <p:spPr>
+          <a:xfrm>
+            <a:off x="4949578" y="2682536"/>
+            <a:ext cx="7242422" cy="3753580"/>
+          </a:xfrm>
+          <a:prstGeom prst="rect">
+            <a:avLst/>
+          </a:prstGeom>
+        </p:spPr>
+      </p:pic>
     </p:spTree>
   </p:cSld>
   <p:clrMapOvr>
@@ -3659,7 +3683,7 @@
 </file>
 
 <file path=ppt/slides/slide11.xml><?xml version="1.0" encoding="utf-8"?>
-<p:sld xmlns:a="http://schemas.openxmlformats.org/drawingml/2006/main" xmlns:p="http://schemas.openxmlformats.org/presentationml/2006/main" xmlns:r="http://schemas.openxmlformats.org/officeDocument/2006/relationships">
+<p:sld xmlns:a="http://schemas.openxmlformats.org/drawingml/2006/main" xmlns:r="http://schemas.openxmlformats.org/officeDocument/2006/relationships" xmlns:p="http://schemas.openxmlformats.org/presentationml/2006/main">
   <p:cSld>
     <p:bg>
       <p:bgPr>
@@ -3675,7 +3699,14 @@
         <p:cNvGrpSpPr/>
         <p:nvPr/>
       </p:nvGrpSpPr>
-      <p:grpSpPr/>
+      <p:grpSpPr>
+        <a:xfrm>
+          <a:off x="0" y="0"/>
+          <a:ext cx="0" cy="0"/>
+          <a:chOff x="0" y="0"/>
+          <a:chExt cx="0" cy="0"/>
+        </a:xfrm>
+      </p:grpSpPr>
       <p:sp>
         <p:nvSpPr>
           <p:cNvPr id="2" name="TextBox 1"/>
@@ -3699,7 +3730,7 @@
           <a:lstStyle/>
           <a:p>
             <a:pPr>
-              <a:defRPr b="1" sz="2800">
+              <a:defRPr sz="2800" b="1">
                 <a:solidFill>
                   <a:srgbClr val="121F36"/>
                 </a:solidFill>
@@ -3790,7 +3821,7 @@
         <p:spPr>
           <a:xfrm>
             <a:off x="685800" y="1417320"/>
-            <a:ext cx="5303520" cy="4114800"/>
+            <a:ext cx="3987800" cy="2164695"/>
           </a:xfrm>
           <a:prstGeom prst="rect">
             <a:avLst/>
@@ -3814,8 +3845,22 @@
               </a:defRPr>
             </a:pPr>
             <a:r>
-              <a:t>CSV-экспорт отчета</a:t>
-            </a:r>
+              <a:rPr dirty="0"/>
+              <a:t>CSV-</a:t>
+            </a:r>
+            <a:r>
+              <a:rPr dirty="0" err="1"/>
+              <a:t>экспорт</a:t>
+            </a:r>
+            <a:r>
+              <a:rPr dirty="0"/>
+              <a:t> </a:t>
+            </a:r>
+            <a:r>
+              <a:rPr dirty="0" err="1"/>
+              <a:t>отчета</a:t>
+            </a:r>
+            <a:endParaRPr dirty="0"/>
           </a:p>
           <a:p>
             <a:pPr>
@@ -3829,8 +3874,14 @@
               </a:defRPr>
             </a:pPr>
             <a:r>
-              <a:t>JWT авторизация</a:t>
-            </a:r>
+              <a:rPr dirty="0"/>
+              <a:t>JWT </a:t>
+            </a:r>
+            <a:r>
+              <a:rPr dirty="0" err="1"/>
+              <a:t>авторизация</a:t>
+            </a:r>
+            <a:endParaRPr dirty="0"/>
           </a:p>
           <a:p>
             <a:pPr>
@@ -3844,8 +3895,22 @@
               </a:defRPr>
             </a:pPr>
             <a:r>
-              <a:t>RBAC по ролям</a:t>
-            </a:r>
+              <a:rPr dirty="0"/>
+              <a:t>RBAC </a:t>
+            </a:r>
+            <a:r>
+              <a:rPr dirty="0" err="1"/>
+              <a:t>по</a:t>
+            </a:r>
+            <a:r>
+              <a:rPr dirty="0"/>
+              <a:t> </a:t>
+            </a:r>
+            <a:r>
+              <a:rPr dirty="0" err="1"/>
+              <a:t>ролям</a:t>
+            </a:r>
+            <a:endParaRPr dirty="0"/>
           </a:p>
           <a:p>
             <a:pPr>
@@ -3859,8 +3924,34 @@
               </a:defRPr>
             </a:pPr>
             <a:r>
-              <a:t>Одобрение новых пользователей администратором</a:t>
-            </a:r>
+              <a:rPr dirty="0" err="1"/>
+              <a:t>Одобрение</a:t>
+            </a:r>
+            <a:r>
+              <a:rPr dirty="0"/>
+              <a:t> </a:t>
+            </a:r>
+            <a:r>
+              <a:rPr dirty="0" err="1"/>
+              <a:t>новых</a:t>
+            </a:r>
+            <a:r>
+              <a:rPr dirty="0"/>
+              <a:t> </a:t>
+            </a:r>
+            <a:r>
+              <a:rPr dirty="0" err="1"/>
+              <a:t>пользователей</a:t>
+            </a:r>
+            <a:r>
+              <a:rPr dirty="0"/>
+              <a:t> </a:t>
+            </a:r>
+            <a:r>
+              <a:rPr dirty="0" err="1"/>
+              <a:t>администратором</a:t>
+            </a:r>
+            <a:endParaRPr dirty="0"/>
           </a:p>
           <a:p>
             <a:pPr>
@@ -3874,69 +3965,100 @@
               </a:defRPr>
             </a:pPr>
             <a:r>
-              <a:t>Запрет чужих действий через API</a:t>
-            </a:r>
-          </a:p>
-        </p:txBody>
-      </p:sp>
-      <p:sp>
-        <p:nvSpPr>
-          <p:cNvPr id="6" name="Rounded Rectangle 5"/>
-          <p:cNvSpPr/>
+              <a:rPr dirty="0" err="1"/>
+              <a:t>Запрет</a:t>
+            </a:r>
+            <a:r>
+              <a:rPr dirty="0"/>
+              <a:t> </a:t>
+            </a:r>
+            <a:r>
+              <a:rPr dirty="0" err="1"/>
+              <a:t>чужих</a:t>
+            </a:r>
+            <a:r>
+              <a:rPr dirty="0"/>
+              <a:t> </a:t>
+            </a:r>
+            <a:r>
+              <a:rPr dirty="0" err="1"/>
+              <a:t>действий</a:t>
+            </a:r>
+            <a:r>
+              <a:rPr dirty="0"/>
+              <a:t> </a:t>
+            </a:r>
+            <a:r>
+              <a:rPr dirty="0" err="1"/>
+              <a:t>через</a:t>
+            </a:r>
+            <a:r>
+              <a:rPr dirty="0"/>
+              <a:t> API</a:t>
+            </a:r>
+          </a:p>
+        </p:txBody>
+      </p:sp>
+      <p:pic>
+        <p:nvPicPr>
+          <p:cNvPr id="8" name="Рисунок 7">
+            <a:extLst>
+              <a:ext uri="{FF2B5EF4-FFF2-40B4-BE49-F238E27FC236}">
+                <a16:creationId xmlns:a16="http://schemas.microsoft.com/office/drawing/2014/main" id="{1DA6DABB-CF98-42B0-8144-B908EDF5A371}"/>
+              </a:ext>
+            </a:extLst>
+          </p:cNvPr>
+          <p:cNvPicPr>
+            <a:picLocks noChangeAspect="1"/>
+          </p:cNvPicPr>
           <p:nvPr/>
-        </p:nvSpPr>
-        <p:spPr>
-          <a:xfrm>
-            <a:off x="6263640" y="1325880"/>
-            <a:ext cx="5212080" cy="4480560"/>
-          </a:xfrm>
-          <a:prstGeom prst="roundRect">
+        </p:nvPicPr>
+        <p:blipFill>
+          <a:blip r:embed="rId2"/>
+          <a:stretch>
+            <a:fillRect/>
+          </a:stretch>
+        </p:blipFill>
+        <p:spPr>
+          <a:xfrm>
+            <a:off x="6096000" y="1"/>
+            <a:ext cx="6096000" cy="3762528"/>
+          </a:xfrm>
+          <a:prstGeom prst="rect">
             <a:avLst/>
           </a:prstGeom>
-          <a:solidFill>
-            <a:srgbClr val="FFFFFF"/>
-          </a:solidFill>
-          <a:ln w="15240">
-            <a:solidFill>
-              <a:srgbClr val="C7D5EB"/>
-            </a:solidFill>
-          </a:ln>
-        </p:spPr>
-        <p:style>
-          <a:lnRef idx="1">
-            <a:schemeClr val="accent1"/>
-          </a:lnRef>
-          <a:fillRef idx="3">
-            <a:schemeClr val="accent1"/>
-          </a:fillRef>
-          <a:effectRef idx="2">
-            <a:schemeClr val="accent1"/>
-          </a:effectRef>
-          <a:fontRef idx="minor">
-            <a:schemeClr val="lt1"/>
-          </a:fontRef>
-        </p:style>
-        <p:txBody>
-          <a:bodyPr rtlCol="0" anchor="ctr"/>
-          <a:lstStyle/>
-          <a:p>
-            <a:pPr algn="ctr">
-              <a:defRPr sz="1800" b="1">
-                <a:solidFill>
-                  <a:srgbClr val="607496"/>
-                </a:solidFill>
-              </a:defRPr>
-            </a:pPr>
-            <a:r>
-              <a:t>Скриншот:</a:t>
-            </a:r>
-            <a:br/>
-            <a:r>
-              <a:t>отчеты, экспорт или админ-пользователи</a:t>
-            </a:r>
-          </a:p>
-        </p:txBody>
-      </p:sp>
+        </p:spPr>
+      </p:pic>
+      <p:pic>
+        <p:nvPicPr>
+          <p:cNvPr id="10" name="Рисунок 9">
+            <a:extLst>
+              <a:ext uri="{FF2B5EF4-FFF2-40B4-BE49-F238E27FC236}">
+                <a16:creationId xmlns:a16="http://schemas.microsoft.com/office/drawing/2014/main" id="{0CF5ECA9-75D1-44CF-94A7-7C97A82BBD32}"/>
+              </a:ext>
+            </a:extLst>
+          </p:cNvPr>
+          <p:cNvPicPr>
+            <a:picLocks noChangeAspect="1"/>
+          </p:cNvPicPr>
+          <p:nvPr/>
+        </p:nvPicPr>
+        <p:blipFill>
+          <a:blip r:embed="rId3"/>
+          <a:stretch>
+            <a:fillRect/>
+          </a:stretch>
+        </p:blipFill>
+        <p:spPr>
+          <a:xfrm>
+            <a:off x="13453" y="3518047"/>
+            <a:ext cx="6182466" cy="3339953"/>
+          </a:xfrm>
+          <a:prstGeom prst="rect">
+            <a:avLst/>
+          </a:prstGeom>
+        </p:spPr>
+      </p:pic>
     </p:spTree>
   </p:cSld>
   <p:clrMapOvr>
@@ -3946,7 +4068,7 @@
 </file>
 
 <file path=ppt/slides/slide12.xml><?xml version="1.0" encoding="utf-8"?>
-<p:sld xmlns:a="http://schemas.openxmlformats.org/drawingml/2006/main" xmlns:p="http://schemas.openxmlformats.org/presentationml/2006/main" xmlns:r="http://schemas.openxmlformats.org/officeDocument/2006/relationships">
+<p:sld xmlns:a="http://schemas.openxmlformats.org/drawingml/2006/main" xmlns:r="http://schemas.openxmlformats.org/officeDocument/2006/relationships" xmlns:p="http://schemas.openxmlformats.org/presentationml/2006/main">
   <p:cSld>
     <p:bg>
       <p:bgPr>
@@ -3962,7 +4084,14 @@
         <p:cNvGrpSpPr/>
         <p:nvPr/>
       </p:nvGrpSpPr>
-      <p:grpSpPr/>
+      <p:grpSpPr>
+        <a:xfrm>
+          <a:off x="0" y="0"/>
+          <a:ext cx="0" cy="0"/>
+          <a:chOff x="0" y="0"/>
+          <a:chExt cx="0" cy="0"/>
+        </a:xfrm>
+      </p:grpSpPr>
       <p:sp>
         <p:nvSpPr>
           <p:cNvPr id="2" name="TextBox 1"/>
@@ -3986,7 +4115,7 @@
           <a:lstStyle/>
           <a:p>
             <a:pPr>
-              <a:defRPr b="1" sz="2800">
+              <a:defRPr sz="2800" b="1">
                 <a:solidFill>
                   <a:srgbClr val="121F36"/>
                 </a:solidFill>
@@ -4166,64 +4295,36 @@
           </a:p>
         </p:txBody>
       </p:sp>
-      <p:sp>
-        <p:nvSpPr>
-          <p:cNvPr id="6" name="Rounded Rectangle 5"/>
-          <p:cNvSpPr/>
+      <p:pic>
+        <p:nvPicPr>
+          <p:cNvPr id="8" name="Рисунок 7">
+            <a:extLst>
+              <a:ext uri="{FF2B5EF4-FFF2-40B4-BE49-F238E27FC236}">
+                <a16:creationId xmlns:a16="http://schemas.microsoft.com/office/drawing/2014/main" id="{1EBA5784-D1C8-41ED-9BD7-637458EDAFF5}"/>
+              </a:ext>
+            </a:extLst>
+          </p:cNvPr>
+          <p:cNvPicPr>
+            <a:picLocks noChangeAspect="1"/>
+          </p:cNvPicPr>
           <p:nvPr/>
-        </p:nvSpPr>
-        <p:spPr>
-          <a:xfrm>
-            <a:off x="6263640" y="1325880"/>
-            <a:ext cx="5212080" cy="4480560"/>
-          </a:xfrm>
-          <a:prstGeom prst="roundRect">
+        </p:nvPicPr>
+        <p:blipFill>
+          <a:blip r:embed="rId2"/>
+          <a:stretch>
+            <a:fillRect/>
+          </a:stretch>
+        </p:blipFill>
+        <p:spPr>
+          <a:xfrm>
+            <a:off x="711200" y="3850681"/>
+            <a:ext cx="10795000" cy="1501480"/>
+          </a:xfrm>
+          <a:prstGeom prst="rect">
             <a:avLst/>
           </a:prstGeom>
-          <a:solidFill>
-            <a:srgbClr val="FFFFFF"/>
-          </a:solidFill>
-          <a:ln w="15240">
-            <a:solidFill>
-              <a:srgbClr val="C7D5EB"/>
-            </a:solidFill>
-          </a:ln>
-        </p:spPr>
-        <p:style>
-          <a:lnRef idx="1">
-            <a:schemeClr val="accent1"/>
-          </a:lnRef>
-          <a:fillRef idx="3">
-            <a:schemeClr val="accent1"/>
-          </a:fillRef>
-          <a:effectRef idx="2">
-            <a:schemeClr val="accent1"/>
-          </a:effectRef>
-          <a:fontRef idx="minor">
-            <a:schemeClr val="lt1"/>
-          </a:fontRef>
-        </p:style>
-        <p:txBody>
-          <a:bodyPr rtlCol="0" anchor="ctr"/>
-          <a:lstStyle/>
-          <a:p>
-            <a:pPr algn="ctr">
-              <a:defRPr sz="1800" b="1">
-                <a:solidFill>
-                  <a:srgbClr val="607496"/>
-                </a:solidFill>
-              </a:defRPr>
-            </a:pPr>
-            <a:r>
-              <a:t>Скриншот:</a:t>
-            </a:r>
-            <a:br/>
-            <a:r>
-              <a:t>папка release или GitHub repository</a:t>
-            </a:r>
-          </a:p>
-        </p:txBody>
-      </p:sp>
+        </p:spPr>
+      </p:pic>
     </p:spTree>
   </p:cSld>
   <p:clrMapOvr>
@@ -4233,7 +4334,7 @@
 </file>
 
 <file path=ppt/slides/slide13.xml><?xml version="1.0" encoding="utf-8"?>
-<p:sld xmlns:a="http://schemas.openxmlformats.org/drawingml/2006/main" xmlns:p="http://schemas.openxmlformats.org/presentationml/2006/main" xmlns:r="http://schemas.openxmlformats.org/officeDocument/2006/relationships">
+<p:sld xmlns:a="http://schemas.openxmlformats.org/drawingml/2006/main" xmlns:r="http://schemas.openxmlformats.org/officeDocument/2006/relationships" xmlns:p="http://schemas.openxmlformats.org/presentationml/2006/main">
   <p:cSld>
     <p:bg>
       <p:bgPr>
@@ -4249,7 +4350,14 @@
         <p:cNvGrpSpPr/>
         <p:nvPr/>
       </p:nvGrpSpPr>
-      <p:grpSpPr/>
+      <p:grpSpPr>
+        <a:xfrm>
+          <a:off x="0" y="0"/>
+          <a:ext cx="0" cy="0"/>
+          <a:chOff x="0" y="0"/>
+          <a:chExt cx="0" cy="0"/>
+        </a:xfrm>
+      </p:grpSpPr>
       <p:sp>
         <p:nvSpPr>
           <p:cNvPr id="2" name="TextBox 1"/>
@@ -4273,7 +4381,7 @@
           <a:lstStyle/>
           <a:p>
             <a:pPr>
-              <a:defRPr b="1" sz="2800">
+              <a:defRPr sz="2800" b="1">
                 <a:solidFill>
                   <a:srgbClr val="121F36"/>
                 </a:solidFill>
@@ -4462,7 +4570,7 @@
 </file>
 
 <file path=ppt/slides/slide2.xml><?xml version="1.0" encoding="utf-8"?>
-<p:sld xmlns:a="http://schemas.openxmlformats.org/drawingml/2006/main" xmlns:p="http://schemas.openxmlformats.org/presentationml/2006/main" xmlns:r="http://schemas.openxmlformats.org/officeDocument/2006/relationships">
+<p:sld xmlns:a="http://schemas.openxmlformats.org/drawingml/2006/main" xmlns:r="http://schemas.openxmlformats.org/officeDocument/2006/relationships" xmlns:p="http://schemas.openxmlformats.org/presentationml/2006/main">
   <p:cSld>
     <p:bg>
       <p:bgPr>
@@ -4478,7 +4586,14 @@
         <p:cNvGrpSpPr/>
         <p:nvPr/>
       </p:nvGrpSpPr>
-      <p:grpSpPr/>
+      <p:grpSpPr>
+        <a:xfrm>
+          <a:off x="0" y="0"/>
+          <a:ext cx="0" cy="0"/>
+          <a:chOff x="0" y="0"/>
+          <a:chExt cx="0" cy="0"/>
+        </a:xfrm>
+      </p:grpSpPr>
       <p:sp>
         <p:nvSpPr>
           <p:cNvPr id="2" name="TextBox 1"/>
@@ -4502,7 +4617,7 @@
           <a:lstStyle/>
           <a:p>
             <a:pPr>
-              <a:defRPr b="1" sz="2800">
+              <a:defRPr sz="2800" b="1">
                 <a:solidFill>
                   <a:srgbClr val="121F36"/>
                 </a:solidFill>
@@ -4592,8 +4707,8 @@
         </p:nvSpPr>
         <p:spPr>
           <a:xfrm>
-            <a:off x="685800" y="1417320"/>
-            <a:ext cx="5486400" cy="4114800"/>
+            <a:off x="685799" y="1417320"/>
+            <a:ext cx="10905067" cy="1508105"/>
           </a:xfrm>
           <a:prstGeom prst="rect">
             <a:avLst/>
@@ -4663,64 +4778,6 @@
             </a:pPr>
             <a:r>
               <a:t>Работник должен быстро отправлять инцидент с телефона.</a:t>
-            </a:r>
-          </a:p>
-        </p:txBody>
-      </p:sp>
-      <p:sp>
-        <p:nvSpPr>
-          <p:cNvPr id="6" name="Rounded Rectangle 5"/>
-          <p:cNvSpPr/>
-          <p:nvPr/>
-        </p:nvSpPr>
-        <p:spPr>
-          <a:xfrm>
-            <a:off x="6400800" y="1417320"/>
-            <a:ext cx="4572000" cy="4206240"/>
-          </a:xfrm>
-          <a:prstGeom prst="roundRect">
-            <a:avLst/>
-          </a:prstGeom>
-          <a:solidFill>
-            <a:srgbClr val="FFFFFF"/>
-          </a:solidFill>
-          <a:ln w="15240">
-            <a:solidFill>
-              <a:srgbClr val="C7D5EB"/>
-            </a:solidFill>
-          </a:ln>
-        </p:spPr>
-        <p:style>
-          <a:lnRef idx="1">
-            <a:schemeClr val="accent1"/>
-          </a:lnRef>
-          <a:fillRef idx="3">
-            <a:schemeClr val="accent1"/>
-          </a:fillRef>
-          <a:effectRef idx="2">
-            <a:schemeClr val="accent1"/>
-          </a:effectRef>
-          <a:fontRef idx="minor">
-            <a:schemeClr val="lt1"/>
-          </a:fontRef>
-        </p:style>
-        <p:txBody>
-          <a:bodyPr rtlCol="0" anchor="ctr"/>
-          <a:lstStyle/>
-          <a:p>
-            <a:pPr algn="ctr">
-              <a:defRPr sz="1800" b="1">
-                <a:solidFill>
-                  <a:srgbClr val="607496"/>
-                </a:solidFill>
-              </a:defRPr>
-            </a:pPr>
-            <a:r>
-              <a:t>Скриншот не обязателен:</a:t>
-            </a:r>
-            <a:br/>
-            <a:r>
-              <a:t>можно оставить схему процесса</a:t>
             </a:r>
           </a:p>
         </p:txBody>
@@ -4734,7 +4791,7 @@
 </file>
 
 <file path=ppt/slides/slide3.xml><?xml version="1.0" encoding="utf-8"?>
-<p:sld xmlns:a="http://schemas.openxmlformats.org/drawingml/2006/main" xmlns:p="http://schemas.openxmlformats.org/presentationml/2006/main" xmlns:r="http://schemas.openxmlformats.org/officeDocument/2006/relationships">
+<p:sld xmlns:a="http://schemas.openxmlformats.org/drawingml/2006/main" xmlns:r="http://schemas.openxmlformats.org/officeDocument/2006/relationships" xmlns:p="http://schemas.openxmlformats.org/presentationml/2006/main">
   <p:cSld>
     <p:bg>
       <p:bgPr>
@@ -4750,7 +4807,14 @@
         <p:cNvGrpSpPr/>
         <p:nvPr/>
       </p:nvGrpSpPr>
-      <p:grpSpPr/>
+      <p:grpSpPr>
+        <a:xfrm>
+          <a:off x="0" y="0"/>
+          <a:ext cx="0" cy="0"/>
+          <a:chOff x="0" y="0"/>
+          <a:chExt cx="0" cy="0"/>
+        </a:xfrm>
+      </p:grpSpPr>
       <p:sp>
         <p:nvSpPr>
           <p:cNvPr id="2" name="TextBox 1"/>
@@ -4774,7 +4838,7 @@
           <a:lstStyle/>
           <a:p>
             <a:pPr>
-              <a:defRPr b="1" sz="2800">
+              <a:defRPr sz="2800" b="1">
                 <a:solidFill>
                   <a:srgbClr val="121F36"/>
                 </a:solidFill>
@@ -4898,7 +4962,7 @@
           <a:lstStyle/>
           <a:p>
             <a:pPr algn="ctr">
-              <a:defRPr b="1" sz="1700">
+              <a:defRPr sz="1700" b="1">
                 <a:solidFill>
                   <a:srgbClr val="16A34A"/>
                 </a:solidFill>
@@ -4964,7 +5028,7 @@
           <a:lstStyle/>
           <a:p>
             <a:pPr algn="ctr">
-              <a:defRPr b="1" sz="1700">
+              <a:defRPr sz="1700" b="1">
                 <a:solidFill>
                   <a:srgbClr val="2563EB"/>
                 </a:solidFill>
@@ -5030,7 +5094,7 @@
           <a:lstStyle/>
           <a:p>
             <a:pPr algn="ctr">
-              <a:defRPr b="1" sz="1700">
+              <a:defRPr sz="1700" b="1">
                 <a:solidFill>
                   <a:srgbClr val="F59E0B"/>
                 </a:solidFill>
@@ -5096,18 +5160,19 @@
           <a:lstStyle/>
           <a:p>
             <a:pPr algn="ctr">
-              <a:defRPr b="1" sz="1700">
+              <a:defRPr sz="1700" b="1">
                 <a:solidFill>
                   <a:srgbClr val="10203D"/>
                 </a:solidFill>
               </a:defRPr>
             </a:pPr>
             <a:r>
+              <a:rPr dirty="0"/>
               <a:t>Flask API + SQLite</a:t>
             </a:r>
           </a:p>
           <a:p>
-            <a:pPr>
+            <a:pPr algn="ctr">
               <a:defRPr sz="1200">
                 <a:solidFill>
                   <a:srgbClr val="607496"/>
@@ -5115,6 +5180,7 @@
               </a:defRPr>
             </a:pPr>
             <a:r>
+              <a:rPr dirty="0"/>
               <a:t>JWT, RBAC, CQRS, BFF, events, audit, reports</a:t>
             </a:r>
           </a:p>
@@ -5129,7 +5195,7 @@
 </file>
 
 <file path=ppt/slides/slide4.xml><?xml version="1.0" encoding="utf-8"?>
-<p:sld xmlns:a="http://schemas.openxmlformats.org/drawingml/2006/main" xmlns:p="http://schemas.openxmlformats.org/presentationml/2006/main" xmlns:r="http://schemas.openxmlformats.org/officeDocument/2006/relationships">
+<p:sld xmlns:a="http://schemas.openxmlformats.org/drawingml/2006/main" xmlns:r="http://schemas.openxmlformats.org/officeDocument/2006/relationships" xmlns:p="http://schemas.openxmlformats.org/presentationml/2006/main">
   <p:cSld>
     <p:bg>
       <p:bgPr>
@@ -5145,7 +5211,14 @@
         <p:cNvGrpSpPr/>
         <p:nvPr/>
       </p:nvGrpSpPr>
-      <p:grpSpPr/>
+      <p:grpSpPr>
+        <a:xfrm>
+          <a:off x="0" y="0"/>
+          <a:ext cx="0" cy="0"/>
+          <a:chOff x="0" y="0"/>
+          <a:chExt cx="0" cy="0"/>
+        </a:xfrm>
+      </p:grpSpPr>
       <p:sp>
         <p:nvSpPr>
           <p:cNvPr id="2" name="TextBox 1"/>
@@ -5169,7 +5242,7 @@
           <a:lstStyle/>
           <a:p>
             <a:pPr>
-              <a:defRPr b="1" sz="2800">
+              <a:defRPr sz="2800" b="1">
                 <a:solidFill>
                   <a:srgbClr val="121F36"/>
                 </a:solidFill>
@@ -5349,64 +5422,36 @@
           </a:p>
         </p:txBody>
       </p:sp>
-      <p:sp>
-        <p:nvSpPr>
-          <p:cNvPr id="6" name="Rounded Rectangle 5"/>
-          <p:cNvSpPr/>
+      <p:pic>
+        <p:nvPicPr>
+          <p:cNvPr id="8" name="Рисунок 7">
+            <a:extLst>
+              <a:ext uri="{FF2B5EF4-FFF2-40B4-BE49-F238E27FC236}">
+                <a16:creationId xmlns:a16="http://schemas.microsoft.com/office/drawing/2014/main" id="{4D7A36C9-4C90-4168-AE80-62447009007E}"/>
+              </a:ext>
+            </a:extLst>
+          </p:cNvPr>
+          <p:cNvPicPr>
+            <a:picLocks noChangeAspect="1"/>
+          </p:cNvPicPr>
           <p:nvPr/>
-        </p:nvSpPr>
-        <p:spPr>
-          <a:xfrm>
-            <a:off x="6263640" y="1325880"/>
-            <a:ext cx="5212080" cy="4480560"/>
-          </a:xfrm>
-          <a:prstGeom prst="roundRect">
+        </p:nvPicPr>
+        <p:blipFill>
+          <a:blip r:embed="rId2"/>
+          <a:stretch>
+            <a:fillRect/>
+          </a:stretch>
+        </p:blipFill>
+        <p:spPr>
+          <a:xfrm>
+            <a:off x="3744962" y="1121240"/>
+            <a:ext cx="8447038" cy="4410880"/>
+          </a:xfrm>
+          <a:prstGeom prst="rect">
             <a:avLst/>
           </a:prstGeom>
-          <a:solidFill>
-            <a:srgbClr val="FFFFFF"/>
-          </a:solidFill>
-          <a:ln w="15240">
-            <a:solidFill>
-              <a:srgbClr val="C7D5EB"/>
-            </a:solidFill>
-          </a:ln>
-        </p:spPr>
-        <p:style>
-          <a:lnRef idx="1">
-            <a:schemeClr val="accent1"/>
-          </a:lnRef>
-          <a:fillRef idx="3">
-            <a:schemeClr val="accent1"/>
-          </a:fillRef>
-          <a:effectRef idx="2">
-            <a:schemeClr val="accent1"/>
-          </a:effectRef>
-          <a:fontRef idx="minor">
-            <a:schemeClr val="lt1"/>
-          </a:fontRef>
-        </p:style>
-        <p:txBody>
-          <a:bodyPr rtlCol="0" anchor="ctr"/>
-          <a:lstStyle/>
-          <a:p>
-            <a:pPr algn="ctr">
-              <a:defRPr sz="1800" b="1">
-                <a:solidFill>
-                  <a:srgbClr val="607496"/>
-                </a:solidFill>
-              </a:defRPr>
-            </a:pPr>
-            <a:r>
-              <a:t>Скриншот:</a:t>
-            </a:r>
-            <a:br/>
-            <a:r>
-              <a:t>журнал рисков или web-меню</a:t>
-            </a:r>
-          </a:p>
-        </p:txBody>
-      </p:sp>
+        </p:spPr>
+      </p:pic>
     </p:spTree>
   </p:cSld>
   <p:clrMapOvr>
@@ -5416,7 +5461,7 @@
 </file>
 
 <file path=ppt/slides/slide5.xml><?xml version="1.0" encoding="utf-8"?>
-<p:sld xmlns:a="http://schemas.openxmlformats.org/drawingml/2006/main" xmlns:p="http://schemas.openxmlformats.org/presentationml/2006/main" xmlns:r="http://schemas.openxmlformats.org/officeDocument/2006/relationships">
+<p:sld xmlns:a="http://schemas.openxmlformats.org/drawingml/2006/main" xmlns:r="http://schemas.openxmlformats.org/officeDocument/2006/relationships" xmlns:p="http://schemas.openxmlformats.org/presentationml/2006/main">
   <p:cSld>
     <p:bg>
       <p:bgPr>
@@ -5432,7 +5477,14 @@
         <p:cNvGrpSpPr/>
         <p:nvPr/>
       </p:nvGrpSpPr>
-      <p:grpSpPr/>
+      <p:grpSpPr>
+        <a:xfrm>
+          <a:off x="0" y="0"/>
+          <a:ext cx="0" cy="0"/>
+          <a:chOff x="0" y="0"/>
+          <a:chExt cx="0" cy="0"/>
+        </a:xfrm>
+      </p:grpSpPr>
       <p:sp>
         <p:nvSpPr>
           <p:cNvPr id="2" name="TextBox 1"/>
@@ -5456,7 +5508,7 @@
           <a:lstStyle/>
           <a:p>
             <a:pPr>
-              <a:defRPr b="1" sz="2800">
+              <a:defRPr sz="2800" b="1">
                 <a:solidFill>
                   <a:srgbClr val="121F36"/>
                 </a:solidFill>
@@ -5547,7 +5599,7 @@
         <p:spPr>
           <a:xfrm>
             <a:off x="685800" y="1417320"/>
-            <a:ext cx="5303520" cy="4114800"/>
+            <a:ext cx="4763626" cy="2062103"/>
           </a:xfrm>
           <a:prstGeom prst="rect">
             <a:avLst/>
@@ -5571,8 +5623,34 @@
               </a:defRPr>
             </a:pPr>
             <a:r>
-              <a:t>Вход и регистрация с одобрением администратора</a:t>
-            </a:r>
+              <a:rPr dirty="0" err="1"/>
+              <a:t>Вход</a:t>
+            </a:r>
+            <a:r>
+              <a:rPr dirty="0"/>
+              <a:t> и </a:t>
+            </a:r>
+            <a:r>
+              <a:rPr dirty="0" err="1"/>
+              <a:t>регистрация</a:t>
+            </a:r>
+            <a:r>
+              <a:rPr dirty="0"/>
+              <a:t> с </a:t>
+            </a:r>
+            <a:r>
+              <a:rPr dirty="0" err="1"/>
+              <a:t>одобрением</a:t>
+            </a:r>
+            <a:r>
+              <a:rPr dirty="0"/>
+              <a:t> </a:t>
+            </a:r>
+            <a:r>
+              <a:rPr dirty="0" err="1"/>
+              <a:t>администратора</a:t>
+            </a:r>
+            <a:endParaRPr dirty="0"/>
           </a:p>
           <a:p>
             <a:pPr>
@@ -5586,7 +5664,36 @@
               </a:defRPr>
             </a:pPr>
             <a:r>
-              <a:t>Настройки сервера для другого ПК</a:t>
+              <a:rPr dirty="0" err="1"/>
+              <a:t>Настройки</a:t>
+            </a:r>
+            <a:r>
+              <a:rPr dirty="0"/>
+              <a:t> </a:t>
+            </a:r>
+            <a:r>
+              <a:rPr dirty="0" err="1"/>
+              <a:t>сервера</a:t>
+            </a:r>
+            <a:r>
+              <a:rPr dirty="0"/>
+              <a:t> </a:t>
+            </a:r>
+            <a:r>
+              <a:rPr dirty="0" err="1"/>
+              <a:t>для</a:t>
+            </a:r>
+            <a:r>
+              <a:rPr dirty="0"/>
+              <a:t> </a:t>
+            </a:r>
+            <a:r>
+              <a:rPr dirty="0" err="1"/>
+              <a:t>другого</a:t>
+            </a:r>
+            <a:r>
+              <a:rPr dirty="0"/>
+              <a:t> ПК</a:t>
             </a:r>
           </a:p>
           <a:p>
@@ -5601,8 +5708,58 @@
               </a:defRPr>
             </a:pPr>
             <a:r>
-              <a:t>Форма инцидента: название, описание, категория, дата, ущерб</a:t>
-            </a:r>
+              <a:rPr dirty="0" err="1"/>
+              <a:t>Форма</a:t>
+            </a:r>
+            <a:r>
+              <a:rPr dirty="0"/>
+              <a:t> </a:t>
+            </a:r>
+            <a:r>
+              <a:rPr dirty="0" err="1"/>
+              <a:t>инцидента</a:t>
+            </a:r>
+            <a:r>
+              <a:rPr dirty="0"/>
+              <a:t>: </a:t>
+            </a:r>
+            <a:r>
+              <a:rPr dirty="0" err="1"/>
+              <a:t>название</a:t>
+            </a:r>
+            <a:r>
+              <a:rPr dirty="0"/>
+              <a:t>, </a:t>
+            </a:r>
+            <a:r>
+              <a:rPr dirty="0" err="1"/>
+              <a:t>описание</a:t>
+            </a:r>
+            <a:r>
+              <a:rPr dirty="0"/>
+              <a:t>, </a:t>
+            </a:r>
+            <a:r>
+              <a:rPr dirty="0" err="1"/>
+              <a:t>категория</a:t>
+            </a:r>
+            <a:r>
+              <a:rPr dirty="0"/>
+              <a:t>, </a:t>
+            </a:r>
+            <a:r>
+              <a:rPr dirty="0" err="1"/>
+              <a:t>дата</a:t>
+            </a:r>
+            <a:r>
+              <a:rPr dirty="0"/>
+              <a:t>, </a:t>
+            </a:r>
+            <a:r>
+              <a:rPr dirty="0" err="1"/>
+              <a:t>ущерб</a:t>
+            </a:r>
+            <a:endParaRPr dirty="0"/>
           </a:p>
           <a:p>
             <a:pPr>
@@ -5616,69 +5773,89 @@
               </a:defRPr>
             </a:pPr>
             <a:r>
-              <a:t>Инцидент уходит в web-очередь</a:t>
-            </a:r>
-          </a:p>
-        </p:txBody>
-      </p:sp>
-      <p:sp>
-        <p:nvSpPr>
-          <p:cNvPr id="6" name="Rounded Rectangle 5"/>
-          <p:cNvSpPr/>
+              <a:rPr dirty="0" err="1"/>
+              <a:t>Инцидент</a:t>
+            </a:r>
+            <a:r>
+              <a:rPr dirty="0"/>
+              <a:t> </a:t>
+            </a:r>
+            <a:r>
+              <a:rPr dirty="0" err="1"/>
+              <a:t>уходит</a:t>
+            </a:r>
+            <a:r>
+              <a:rPr dirty="0"/>
+              <a:t> в web-</a:t>
+            </a:r>
+            <a:r>
+              <a:rPr dirty="0" err="1"/>
+              <a:t>очередь</a:t>
+            </a:r>
+            <a:endParaRPr dirty="0"/>
+          </a:p>
+        </p:txBody>
+      </p:sp>
+      <p:pic>
+        <p:nvPicPr>
+          <p:cNvPr id="8" name="Рисунок 7">
+            <a:extLst>
+              <a:ext uri="{FF2B5EF4-FFF2-40B4-BE49-F238E27FC236}">
+                <a16:creationId xmlns:a16="http://schemas.microsoft.com/office/drawing/2014/main" id="{5F33FDED-F4BC-4406-8F44-D7985945E7D4}"/>
+              </a:ext>
+            </a:extLst>
+          </p:cNvPr>
+          <p:cNvPicPr>
+            <a:picLocks noChangeAspect="1"/>
+          </p:cNvPicPr>
           <p:nvPr/>
-        </p:nvSpPr>
-        <p:spPr>
-          <a:xfrm>
-            <a:off x="6263640" y="1325880"/>
-            <a:ext cx="5212080" cy="4480560"/>
-          </a:xfrm>
-          <a:prstGeom prst="roundRect">
+        </p:nvPicPr>
+        <p:blipFill>
+          <a:blip r:embed="rId2"/>
+          <a:stretch>
+            <a:fillRect/>
+          </a:stretch>
+        </p:blipFill>
+        <p:spPr>
+          <a:xfrm>
+            <a:off x="8779819" y="228600"/>
+            <a:ext cx="3412181" cy="6104467"/>
+          </a:xfrm>
+          <a:prstGeom prst="rect">
             <a:avLst/>
           </a:prstGeom>
-          <a:solidFill>
-            <a:srgbClr val="FFFFFF"/>
-          </a:solidFill>
-          <a:ln w="15240">
-            <a:solidFill>
-              <a:srgbClr val="C7D5EB"/>
-            </a:solidFill>
-          </a:ln>
-        </p:spPr>
-        <p:style>
-          <a:lnRef idx="1">
-            <a:schemeClr val="accent1"/>
-          </a:lnRef>
-          <a:fillRef idx="3">
-            <a:schemeClr val="accent1"/>
-          </a:fillRef>
-          <a:effectRef idx="2">
-            <a:schemeClr val="accent1"/>
-          </a:effectRef>
-          <a:fontRef idx="minor">
-            <a:schemeClr val="lt1"/>
-          </a:fontRef>
-        </p:style>
-        <p:txBody>
-          <a:bodyPr rtlCol="0" anchor="ctr"/>
-          <a:lstStyle/>
-          <a:p>
-            <a:pPr algn="ctr">
-              <a:defRPr sz="1800" b="1">
-                <a:solidFill>
-                  <a:srgbClr val="607496"/>
-                </a:solidFill>
-              </a:defRPr>
-            </a:pPr>
-            <a:r>
-              <a:t>Скриншот:</a:t>
-            </a:r>
-            <a:br/>
-            <a:r>
-              <a:t>APK вход + форма инцидента</a:t>
-            </a:r>
-          </a:p>
-        </p:txBody>
-      </p:sp>
+        </p:spPr>
+      </p:pic>
+      <p:pic>
+        <p:nvPicPr>
+          <p:cNvPr id="10" name="Рисунок 9">
+            <a:extLst>
+              <a:ext uri="{FF2B5EF4-FFF2-40B4-BE49-F238E27FC236}">
+                <a16:creationId xmlns:a16="http://schemas.microsoft.com/office/drawing/2014/main" id="{57D462EE-7D0A-4215-84C0-8D2B70CB95E1}"/>
+              </a:ext>
+            </a:extLst>
+          </p:cNvPr>
+          <p:cNvPicPr>
+            <a:picLocks noChangeAspect="1"/>
+          </p:cNvPicPr>
+          <p:nvPr/>
+        </p:nvPicPr>
+        <p:blipFill>
+          <a:blip r:embed="rId3"/>
+          <a:stretch>
+            <a:fillRect/>
+          </a:stretch>
+        </p:blipFill>
+        <p:spPr>
+          <a:xfrm>
+            <a:off x="5449426" y="228600"/>
+            <a:ext cx="3439957" cy="6104467"/>
+          </a:xfrm>
+          <a:prstGeom prst="rect">
+            <a:avLst/>
+          </a:prstGeom>
+        </p:spPr>
+      </p:pic>
     </p:spTree>
   </p:cSld>
   <p:clrMapOvr>
@@ -5688,7 +5865,7 @@
 </file>
 
 <file path=ppt/slides/slide6.xml><?xml version="1.0" encoding="utf-8"?>
-<p:sld xmlns:a="http://schemas.openxmlformats.org/drawingml/2006/main" xmlns:p="http://schemas.openxmlformats.org/presentationml/2006/main" xmlns:r="http://schemas.openxmlformats.org/officeDocument/2006/relationships">
+<p:sld xmlns:a="http://schemas.openxmlformats.org/drawingml/2006/main" xmlns:r="http://schemas.openxmlformats.org/officeDocument/2006/relationships" xmlns:p="http://schemas.openxmlformats.org/presentationml/2006/main">
   <p:cSld>
     <p:bg>
       <p:bgPr>
@@ -5704,7 +5881,14 @@
         <p:cNvGrpSpPr/>
         <p:nvPr/>
       </p:nvGrpSpPr>
-      <p:grpSpPr/>
+      <p:grpSpPr>
+        <a:xfrm>
+          <a:off x="0" y="0"/>
+          <a:ext cx="0" cy="0"/>
+          <a:chOff x="0" y="0"/>
+          <a:chExt cx="0" cy="0"/>
+        </a:xfrm>
+      </p:grpSpPr>
       <p:sp>
         <p:nvSpPr>
           <p:cNvPr id="2" name="TextBox 1"/>
@@ -5728,7 +5912,7 @@
           <a:lstStyle/>
           <a:p>
             <a:pPr>
-              <a:defRPr b="1" sz="2800">
+              <a:defRPr sz="2800" b="1">
                 <a:solidFill>
                   <a:srgbClr val="121F36"/>
                 </a:solidFill>
@@ -5818,8 +6002,8 @@
         </p:nvSpPr>
         <p:spPr>
           <a:xfrm>
-            <a:off x="685800" y="1417320"/>
-            <a:ext cx="5303520" cy="4114800"/>
+            <a:off x="685799" y="1417320"/>
+            <a:ext cx="10778067" cy="1508105"/>
           </a:xfrm>
           <a:prstGeom prst="rect">
             <a:avLst/>
@@ -5843,7 +6027,44 @@
               </a:defRPr>
             </a:pPr>
             <a:r>
-              <a:t>Работник не создает риск напрямую.</a:t>
+              <a:rPr dirty="0" err="1"/>
+              <a:t>Работник</a:t>
+            </a:r>
+            <a:r>
+              <a:rPr dirty="0"/>
+              <a:t> </a:t>
+            </a:r>
+            <a:r>
+              <a:rPr dirty="0" err="1"/>
+              <a:t>не</a:t>
+            </a:r>
+            <a:r>
+              <a:rPr dirty="0"/>
+              <a:t> </a:t>
+            </a:r>
+            <a:r>
+              <a:rPr dirty="0" err="1"/>
+              <a:t>создает</a:t>
+            </a:r>
+            <a:r>
+              <a:rPr dirty="0"/>
+              <a:t> </a:t>
+            </a:r>
+            <a:r>
+              <a:rPr dirty="0" err="1"/>
+              <a:t>риск</a:t>
+            </a:r>
+            <a:r>
+              <a:rPr dirty="0"/>
+              <a:t> </a:t>
+            </a:r>
+            <a:r>
+              <a:rPr dirty="0" err="1"/>
+              <a:t>напрямую</a:t>
+            </a:r>
+            <a:r>
+              <a:rPr dirty="0"/>
+              <a:t>.</a:t>
             </a:r>
           </a:p>
           <a:p>
@@ -5858,7 +6079,36 @@
               </a:defRPr>
             </a:pPr>
             <a:r>
-              <a:t>Менеджер проверяет входящий инцидент.</a:t>
+              <a:rPr dirty="0" err="1"/>
+              <a:t>Менеджер</a:t>
+            </a:r>
+            <a:r>
+              <a:rPr dirty="0"/>
+              <a:t> </a:t>
+            </a:r>
+            <a:r>
+              <a:rPr dirty="0" err="1"/>
+              <a:t>проверяет</a:t>
+            </a:r>
+            <a:r>
+              <a:rPr dirty="0"/>
+              <a:t> </a:t>
+            </a:r>
+            <a:r>
+              <a:rPr dirty="0" err="1"/>
+              <a:t>входящий</a:t>
+            </a:r>
+            <a:r>
+              <a:rPr dirty="0"/>
+              <a:t> </a:t>
+            </a:r>
+            <a:r>
+              <a:rPr dirty="0" err="1"/>
+              <a:t>инцидент</a:t>
+            </a:r>
+            <a:r>
+              <a:rPr dirty="0"/>
+              <a:t>.</a:t>
             </a:r>
           </a:p>
           <a:p>
@@ -5873,7 +6123,44 @@
               </a:defRPr>
             </a:pPr>
             <a:r>
-              <a:t>После проверки нажимает 'Создать риск'.</a:t>
+              <a:rPr dirty="0" err="1"/>
+              <a:t>После</a:t>
+            </a:r>
+            <a:r>
+              <a:rPr dirty="0"/>
+              <a:t> </a:t>
+            </a:r>
+            <a:r>
+              <a:rPr dirty="0" err="1"/>
+              <a:t>проверки</a:t>
+            </a:r>
+            <a:r>
+              <a:rPr dirty="0"/>
+              <a:t> </a:t>
+            </a:r>
+            <a:r>
+              <a:rPr dirty="0" err="1"/>
+              <a:t>нажимает</a:t>
+            </a:r>
+            <a:r>
+              <a:rPr dirty="0"/>
+              <a:t> '</a:t>
+            </a:r>
+            <a:r>
+              <a:rPr dirty="0" err="1"/>
+              <a:t>Создать</a:t>
+            </a:r>
+            <a:r>
+              <a:rPr dirty="0"/>
+              <a:t> </a:t>
+            </a:r>
+            <a:r>
+              <a:rPr dirty="0" err="1"/>
+              <a:t>риск</a:t>
+            </a:r>
+            <a:r>
+              <a:rPr dirty="0"/>
+              <a:t>'.</a:t>
             </a:r>
           </a:p>
           <a:p>
@@ -5888,73 +6175,94 @@
               </a:defRPr>
             </a:pPr>
             <a:r>
-              <a:t>Риск появляется в журнале и может быть назначен эксперту.</a:t>
-            </a:r>
-          </a:p>
-        </p:txBody>
-      </p:sp>
-      <p:sp>
-        <p:nvSpPr>
-          <p:cNvPr id="6" name="Rounded Rectangle 5"/>
-          <p:cNvSpPr/>
+              <a:rPr dirty="0" err="1"/>
+              <a:t>Риск</a:t>
+            </a:r>
+            <a:r>
+              <a:rPr dirty="0"/>
+              <a:t> </a:t>
+            </a:r>
+            <a:r>
+              <a:rPr dirty="0" err="1"/>
+              <a:t>появляется</a:t>
+            </a:r>
+            <a:r>
+              <a:rPr dirty="0"/>
+              <a:t> в </a:t>
+            </a:r>
+            <a:r>
+              <a:rPr dirty="0" err="1"/>
+              <a:t>журнале</a:t>
+            </a:r>
+            <a:r>
+              <a:rPr dirty="0"/>
+              <a:t> и </a:t>
+            </a:r>
+            <a:r>
+              <a:rPr dirty="0" err="1"/>
+              <a:t>может</a:t>
+            </a:r>
+            <a:r>
+              <a:rPr dirty="0"/>
+              <a:t> </a:t>
+            </a:r>
+            <a:r>
+              <a:rPr dirty="0" err="1"/>
+              <a:t>быть</a:t>
+            </a:r>
+            <a:r>
+              <a:rPr dirty="0"/>
+              <a:t> </a:t>
+            </a:r>
+            <a:r>
+              <a:rPr dirty="0" err="1"/>
+              <a:t>назначен</a:t>
+            </a:r>
+            <a:r>
+              <a:rPr dirty="0"/>
+              <a:t> </a:t>
+            </a:r>
+            <a:r>
+              <a:rPr dirty="0" err="1"/>
+              <a:t>эксперту</a:t>
+            </a:r>
+            <a:r>
+              <a:rPr dirty="0"/>
+              <a:t>.</a:t>
+            </a:r>
+          </a:p>
+        </p:txBody>
+      </p:sp>
+      <p:pic>
+        <p:nvPicPr>
+          <p:cNvPr id="8" name="Рисунок 7">
+            <a:extLst>
+              <a:ext uri="{FF2B5EF4-FFF2-40B4-BE49-F238E27FC236}">
+                <a16:creationId xmlns:a16="http://schemas.microsoft.com/office/drawing/2014/main" id="{46CAD8E3-5509-4D48-8CAD-B0C342BE8DB4}"/>
+              </a:ext>
+            </a:extLst>
+          </p:cNvPr>
+          <p:cNvPicPr>
+            <a:picLocks noChangeAspect="1"/>
+          </p:cNvPicPr>
           <p:nvPr/>
-        </p:nvSpPr>
-        <p:spPr>
-          <a:xfrm>
-            <a:off x="6263640" y="1325880"/>
-            <a:ext cx="5212080" cy="4480560"/>
-          </a:xfrm>
-          <a:prstGeom prst="roundRect">
+        </p:nvPicPr>
+        <p:blipFill>
+          <a:blip r:embed="rId2"/>
+          <a:stretch>
+            <a:fillRect/>
+          </a:stretch>
+        </p:blipFill>
+        <p:spPr>
+          <a:xfrm>
+            <a:off x="579966" y="3474720"/>
+            <a:ext cx="11032067" cy="2200678"/>
+          </a:xfrm>
+          <a:prstGeom prst="rect">
             <a:avLst/>
           </a:prstGeom>
-          <a:solidFill>
-            <a:srgbClr val="FFFFFF"/>
-          </a:solidFill>
-          <a:ln w="15240">
-            <a:solidFill>
-              <a:srgbClr val="C7D5EB"/>
-            </a:solidFill>
-          </a:ln>
-        </p:spPr>
-        <p:style>
-          <a:lnRef idx="1">
-            <a:schemeClr val="accent1"/>
-          </a:lnRef>
-          <a:fillRef idx="3">
-            <a:schemeClr val="accent1"/>
-          </a:fillRef>
-          <a:effectRef idx="2">
-            <a:schemeClr val="accent1"/>
-          </a:effectRef>
-          <a:fontRef idx="minor">
-            <a:schemeClr val="lt1"/>
-          </a:fontRef>
-        </p:style>
-        <p:txBody>
-          <a:bodyPr rtlCol="0" anchor="ctr"/>
-          <a:lstStyle/>
-          <a:p>
-            <a:pPr algn="ctr">
-              <a:defRPr sz="1800" b="1">
-                <a:solidFill>
-                  <a:srgbClr val="607496"/>
-                </a:solidFill>
-              </a:defRPr>
-            </a:pPr>
-            <a:r>
-              <a:t>Скриншот:</a:t>
-            </a:r>
-            <a:br/>
-            <a:r>
-              <a:t>web очередь инцидентов</a:t>
-            </a:r>
-            <a:br/>
-            <a:r>
-              <a:t>и кнопка 'Создать риск'</a:t>
-            </a:r>
-          </a:p>
-        </p:txBody>
-      </p:sp>
+        </p:spPr>
+      </p:pic>
     </p:spTree>
   </p:cSld>
   <p:clrMapOvr>
@@ -5964,7 +6272,7 @@
 </file>
 
 <file path=ppt/slides/slide7.xml><?xml version="1.0" encoding="utf-8"?>
-<p:sld xmlns:a="http://schemas.openxmlformats.org/drawingml/2006/main" xmlns:p="http://schemas.openxmlformats.org/presentationml/2006/main" xmlns:r="http://schemas.openxmlformats.org/officeDocument/2006/relationships">
+<p:sld xmlns:a="http://schemas.openxmlformats.org/drawingml/2006/main" xmlns:r="http://schemas.openxmlformats.org/officeDocument/2006/relationships" xmlns:p="http://schemas.openxmlformats.org/presentationml/2006/main">
   <p:cSld>
     <p:bg>
       <p:bgPr>
@@ -5980,7 +6288,14 @@
         <p:cNvGrpSpPr/>
         <p:nvPr/>
       </p:nvGrpSpPr>
-      <p:grpSpPr/>
+      <p:grpSpPr>
+        <a:xfrm>
+          <a:off x="0" y="0"/>
+          <a:ext cx="0" cy="0"/>
+          <a:chOff x="0" y="0"/>
+          <a:chExt cx="0" cy="0"/>
+        </a:xfrm>
+      </p:grpSpPr>
       <p:sp>
         <p:nvSpPr>
           <p:cNvPr id="2" name="TextBox 1"/>
@@ -6004,7 +6319,7 @@
           <a:lstStyle/>
           <a:p>
             <a:pPr>
-              <a:defRPr b="1" sz="2800">
+              <a:defRPr sz="2800" b="1">
                 <a:solidFill>
                   <a:srgbClr val="121F36"/>
                 </a:solidFill>
@@ -6094,8 +6409,8 @@
         </p:nvSpPr>
         <p:spPr>
           <a:xfrm>
-            <a:off x="685800" y="1417320"/>
-            <a:ext cx="5303520" cy="4114800"/>
+            <a:off x="67733" y="1527387"/>
+            <a:ext cx="3699933" cy="2616101"/>
           </a:xfrm>
           <a:prstGeom prst="rect">
             <a:avLst/>
@@ -6119,8 +6434,18 @@
               </a:defRPr>
             </a:pPr>
             <a:r>
-              <a:t>Статусы: CREATED, ACTIVE, COMPLETED, CANCELLED</a:t>
-            </a:r>
+              <a:rPr dirty="0" err="1"/>
+              <a:t>Статусы</a:t>
+            </a:r>
+            <a:r>
+              <a:rPr dirty="0"/>
+              <a:t>: CREATED, ACTIVE, COMPLETED, CANCELLED</a:t>
+            </a:r>
+            <a:r>
+              <a:rPr lang="en-US" dirty="0"/>
+              <a:t>.</a:t>
+            </a:r>
+            <a:endParaRPr dirty="0"/>
           </a:p>
           <a:p>
             <a:pPr>
@@ -6134,8 +6459,34 @@
               </a:defRPr>
             </a:pPr>
             <a:r>
-              <a:t>ACTIVE требует назначенного эксперта</a:t>
-            </a:r>
+              <a:rPr dirty="0"/>
+              <a:t>ACTIVE </a:t>
+            </a:r>
+            <a:r>
+              <a:rPr dirty="0" err="1"/>
+              <a:t>требует</a:t>
+            </a:r>
+            <a:r>
+              <a:rPr dirty="0"/>
+              <a:t> </a:t>
+            </a:r>
+            <a:r>
+              <a:rPr dirty="0" err="1"/>
+              <a:t>назначенного</a:t>
+            </a:r>
+            <a:r>
+              <a:rPr dirty="0"/>
+              <a:t> </a:t>
+            </a:r>
+            <a:r>
+              <a:rPr dirty="0" err="1"/>
+              <a:t>эксперта</a:t>
+            </a:r>
+            <a:r>
+              <a:rPr lang="en-US" dirty="0"/>
+              <a:t>.</a:t>
+            </a:r>
+            <a:endParaRPr dirty="0"/>
           </a:p>
           <a:p>
             <a:pPr>
@@ -6149,8 +6500,54 @@
               </a:defRPr>
             </a:pPr>
             <a:r>
-              <a:t>Завершенные и отмененные риски нельзя вернуть в работу</a:t>
-            </a:r>
+              <a:rPr dirty="0" err="1"/>
+              <a:t>Завершенные</a:t>
+            </a:r>
+            <a:r>
+              <a:rPr dirty="0"/>
+              <a:t> и </a:t>
+            </a:r>
+            <a:r>
+              <a:rPr dirty="0" err="1"/>
+              <a:t>отмененные</a:t>
+            </a:r>
+            <a:r>
+              <a:rPr dirty="0"/>
+              <a:t> </a:t>
+            </a:r>
+            <a:r>
+              <a:rPr dirty="0" err="1"/>
+              <a:t>риски</a:t>
+            </a:r>
+            <a:r>
+              <a:rPr dirty="0"/>
+              <a:t> </a:t>
+            </a:r>
+            <a:r>
+              <a:rPr dirty="0" err="1"/>
+              <a:t>нельзя</a:t>
+            </a:r>
+            <a:r>
+              <a:rPr dirty="0"/>
+              <a:t> </a:t>
+            </a:r>
+            <a:r>
+              <a:rPr dirty="0" err="1"/>
+              <a:t>вернуть</a:t>
+            </a:r>
+            <a:r>
+              <a:rPr dirty="0"/>
+              <a:t> в </a:t>
+            </a:r>
+            <a:r>
+              <a:rPr dirty="0" err="1"/>
+              <a:t>работу</a:t>
+            </a:r>
+            <a:r>
+              <a:rPr lang="en-US" dirty="0"/>
+              <a:t>.</a:t>
+            </a:r>
+            <a:endParaRPr dirty="0"/>
           </a:p>
           <a:p>
             <a:pPr>
@@ -6164,69 +6561,79 @@
               </a:defRPr>
             </a:pPr>
             <a:r>
-              <a:t>Меры минимизации хранятся вместе с риском</a:t>
-            </a:r>
-          </a:p>
-        </p:txBody>
-      </p:sp>
-      <p:sp>
-        <p:nvSpPr>
-          <p:cNvPr id="6" name="Rounded Rectangle 5"/>
-          <p:cNvSpPr/>
+              <a:rPr dirty="0" err="1"/>
+              <a:t>Меры</a:t>
+            </a:r>
+            <a:r>
+              <a:rPr dirty="0"/>
+              <a:t> </a:t>
+            </a:r>
+            <a:r>
+              <a:rPr dirty="0" err="1"/>
+              <a:t>минимизации</a:t>
+            </a:r>
+            <a:r>
+              <a:rPr dirty="0"/>
+              <a:t> </a:t>
+            </a:r>
+            <a:r>
+              <a:rPr dirty="0" err="1"/>
+              <a:t>хранятся</a:t>
+            </a:r>
+            <a:r>
+              <a:rPr dirty="0"/>
+              <a:t> </a:t>
+            </a:r>
+            <a:r>
+              <a:rPr dirty="0" err="1"/>
+              <a:t>вместе</a:t>
+            </a:r>
+            <a:r>
+              <a:rPr dirty="0"/>
+              <a:t> с </a:t>
+            </a:r>
+            <a:r>
+              <a:rPr dirty="0" err="1"/>
+              <a:t>риском</a:t>
+            </a:r>
+            <a:r>
+              <a:rPr lang="en-US" dirty="0"/>
+              <a:t>.</a:t>
+            </a:r>
+            <a:endParaRPr dirty="0"/>
+          </a:p>
+        </p:txBody>
+      </p:sp>
+      <p:pic>
+        <p:nvPicPr>
+          <p:cNvPr id="10" name="Рисунок 9">
+            <a:extLst>
+              <a:ext uri="{FF2B5EF4-FFF2-40B4-BE49-F238E27FC236}">
+                <a16:creationId xmlns:a16="http://schemas.microsoft.com/office/drawing/2014/main" id="{4C4BF75F-3E1A-434F-AB0F-81ECC91EF291}"/>
+              </a:ext>
+            </a:extLst>
+          </p:cNvPr>
+          <p:cNvPicPr>
+            <a:picLocks noChangeAspect="1"/>
+          </p:cNvPicPr>
           <p:nvPr/>
-        </p:nvSpPr>
-        <p:spPr>
-          <a:xfrm>
-            <a:off x="6263640" y="1325880"/>
-            <a:ext cx="5212080" cy="4480560"/>
-          </a:xfrm>
-          <a:prstGeom prst="roundRect">
+        </p:nvPicPr>
+        <p:blipFill>
+          <a:blip r:embed="rId2"/>
+          <a:stretch>
+            <a:fillRect/>
+          </a:stretch>
+        </p:blipFill>
+        <p:spPr>
+          <a:xfrm>
+            <a:off x="3622297" y="1457374"/>
+            <a:ext cx="8569703" cy="3783732"/>
+          </a:xfrm>
+          <a:prstGeom prst="rect">
             <a:avLst/>
           </a:prstGeom>
-          <a:solidFill>
-            <a:srgbClr val="FFFFFF"/>
-          </a:solidFill>
-          <a:ln w="15240">
-            <a:solidFill>
-              <a:srgbClr val="C7D5EB"/>
-            </a:solidFill>
-          </a:ln>
-        </p:spPr>
-        <p:style>
-          <a:lnRef idx="1">
-            <a:schemeClr val="accent1"/>
-          </a:lnRef>
-          <a:fillRef idx="3">
-            <a:schemeClr val="accent1"/>
-          </a:fillRef>
-          <a:effectRef idx="2">
-            <a:schemeClr val="accent1"/>
-          </a:effectRef>
-          <a:fontRef idx="minor">
-            <a:schemeClr val="lt1"/>
-          </a:fontRef>
-        </p:style>
-        <p:txBody>
-          <a:bodyPr rtlCol="0" anchor="ctr"/>
-          <a:lstStyle/>
-          <a:p>
-            <a:pPr algn="ctr">
-              <a:defRPr sz="1800" b="1">
-                <a:solidFill>
-                  <a:srgbClr val="607496"/>
-                </a:solidFill>
-              </a:defRPr>
-            </a:pPr>
-            <a:r>
-              <a:t>Скриншот:</a:t>
-            </a:r>
-            <a:br/>
-            <a:r>
-              <a:t>карточка риска или форма плана минимизации</a:t>
-            </a:r>
-          </a:p>
-        </p:txBody>
-      </p:sp>
+        </p:spPr>
+      </p:pic>
     </p:spTree>
   </p:cSld>
   <p:clrMapOvr>
@@ -6236,7 +6643,7 @@
 </file>
 
 <file path=ppt/slides/slide8.xml><?xml version="1.0" encoding="utf-8"?>
-<p:sld xmlns:a="http://schemas.openxmlformats.org/drawingml/2006/main" xmlns:p="http://schemas.openxmlformats.org/presentationml/2006/main" xmlns:r="http://schemas.openxmlformats.org/officeDocument/2006/relationships">
+<p:sld xmlns:a="http://schemas.openxmlformats.org/drawingml/2006/main" xmlns:r="http://schemas.openxmlformats.org/officeDocument/2006/relationships" xmlns:p="http://schemas.openxmlformats.org/presentationml/2006/main">
   <p:cSld>
     <p:bg>
       <p:bgPr>
@@ -6252,7 +6659,14 @@
         <p:cNvGrpSpPr/>
         <p:nvPr/>
       </p:nvGrpSpPr>
-      <p:grpSpPr/>
+      <p:grpSpPr>
+        <a:xfrm>
+          <a:off x="0" y="0"/>
+          <a:ext cx="0" cy="0"/>
+          <a:chOff x="0" y="0"/>
+          <a:chExt cx="0" cy="0"/>
+        </a:xfrm>
+      </p:grpSpPr>
       <p:sp>
         <p:nvSpPr>
           <p:cNvPr id="2" name="TextBox 1"/>
@@ -6276,7 +6690,7 @@
           <a:lstStyle/>
           <a:p>
             <a:pPr>
-              <a:defRPr b="1" sz="2800">
+              <a:defRPr sz="2800" b="1">
                 <a:solidFill>
                   <a:srgbClr val="121F36"/>
                 </a:solidFill>
@@ -6366,8 +6780,8 @@
         </p:nvSpPr>
         <p:spPr>
           <a:xfrm>
-            <a:off x="685800" y="1417320"/>
-            <a:ext cx="5303520" cy="4114800"/>
+            <a:off x="245534" y="1429173"/>
+            <a:ext cx="3698052" cy="2062103"/>
           </a:xfrm>
           <a:prstGeom prst="rect">
             <a:avLst/>
@@ -6391,8 +6805,50 @@
               </a:defRPr>
             </a:pPr>
             <a:r>
-              <a:t>Эксперт видит только назначенные ему риски</a:t>
-            </a:r>
+              <a:rPr dirty="0" err="1"/>
+              <a:t>Эксперт</a:t>
+            </a:r>
+            <a:r>
+              <a:rPr dirty="0"/>
+              <a:t> </a:t>
+            </a:r>
+            <a:r>
+              <a:rPr dirty="0" err="1"/>
+              <a:t>видит</a:t>
+            </a:r>
+            <a:r>
+              <a:rPr dirty="0"/>
+              <a:t> </a:t>
+            </a:r>
+            <a:r>
+              <a:rPr dirty="0" err="1"/>
+              <a:t>только</a:t>
+            </a:r>
+            <a:r>
+              <a:rPr dirty="0"/>
+              <a:t> </a:t>
+            </a:r>
+            <a:r>
+              <a:rPr dirty="0" err="1"/>
+              <a:t>назначенные</a:t>
+            </a:r>
+            <a:r>
+              <a:rPr dirty="0"/>
+              <a:t> </a:t>
+            </a:r>
+            <a:r>
+              <a:rPr dirty="0" err="1"/>
+              <a:t>ему</a:t>
+            </a:r>
+            <a:r>
+              <a:rPr dirty="0"/>
+              <a:t> </a:t>
+            </a:r>
+            <a:r>
+              <a:rPr dirty="0" err="1"/>
+              <a:t>риски</a:t>
+            </a:r>
+            <a:endParaRPr dirty="0"/>
           </a:p>
           <a:p>
             <a:pPr>
@@ -6406,8 +6862,34 @@
               </a:defRPr>
             </a:pPr>
             <a:r>
-              <a:t>Есть список назначенных рисков</a:t>
-            </a:r>
+              <a:rPr dirty="0" err="1"/>
+              <a:t>Есть</a:t>
+            </a:r>
+            <a:r>
+              <a:rPr dirty="0"/>
+              <a:t> </a:t>
+            </a:r>
+            <a:r>
+              <a:rPr dirty="0" err="1"/>
+              <a:t>список</a:t>
+            </a:r>
+            <a:r>
+              <a:rPr dirty="0"/>
+              <a:t> </a:t>
+            </a:r>
+            <a:r>
+              <a:rPr dirty="0" err="1"/>
+              <a:t>назначенных</a:t>
+            </a:r>
+            <a:r>
+              <a:rPr dirty="0"/>
+              <a:t> </a:t>
+            </a:r>
+            <a:r>
+              <a:rPr dirty="0" err="1"/>
+              <a:t>рисков</a:t>
+            </a:r>
+            <a:endParaRPr dirty="0"/>
           </a:p>
           <a:p>
             <a:pPr>
@@ -6421,8 +6903,34 @@
               </a:defRPr>
             </a:pPr>
             <a:r>
-              <a:t>Есть раздел отправленных оценок</a:t>
-            </a:r>
+              <a:rPr dirty="0" err="1"/>
+              <a:t>Есть</a:t>
+            </a:r>
+            <a:r>
+              <a:rPr dirty="0"/>
+              <a:t> </a:t>
+            </a:r>
+            <a:r>
+              <a:rPr dirty="0" err="1"/>
+              <a:t>раздел</a:t>
+            </a:r>
+            <a:r>
+              <a:rPr dirty="0"/>
+              <a:t> </a:t>
+            </a:r>
+            <a:r>
+              <a:rPr dirty="0" err="1"/>
+              <a:t>отправленных</a:t>
+            </a:r>
+            <a:r>
+              <a:rPr dirty="0"/>
+              <a:t> </a:t>
+            </a:r>
+            <a:r>
+              <a:rPr dirty="0" err="1"/>
+              <a:t>оценок</a:t>
+            </a:r>
+            <a:endParaRPr dirty="0"/>
           </a:p>
           <a:p>
             <a:pPr>
@@ -6436,69 +6944,67 @@
               </a:defRPr>
             </a:pPr>
             <a:r>
-              <a:t>Профиль показывает статистику эксперта</a:t>
-            </a:r>
-          </a:p>
-        </p:txBody>
-      </p:sp>
-      <p:sp>
-        <p:nvSpPr>
-          <p:cNvPr id="6" name="Rounded Rectangle 5"/>
-          <p:cNvSpPr/>
+              <a:rPr dirty="0" err="1"/>
+              <a:t>Профиль</a:t>
+            </a:r>
+            <a:r>
+              <a:rPr dirty="0"/>
+              <a:t> </a:t>
+            </a:r>
+            <a:r>
+              <a:rPr dirty="0" err="1"/>
+              <a:t>показывает</a:t>
+            </a:r>
+            <a:r>
+              <a:rPr dirty="0"/>
+              <a:t> </a:t>
+            </a:r>
+            <a:r>
+              <a:rPr dirty="0" err="1"/>
+              <a:t>статистику</a:t>
+            </a:r>
+            <a:r>
+              <a:rPr dirty="0"/>
+              <a:t> </a:t>
+            </a:r>
+            <a:r>
+              <a:rPr dirty="0" err="1"/>
+              <a:t>эксперта</a:t>
+            </a:r>
+            <a:endParaRPr dirty="0"/>
+          </a:p>
+        </p:txBody>
+      </p:sp>
+      <p:pic>
+        <p:nvPicPr>
+          <p:cNvPr id="8" name="Рисунок 7">
+            <a:extLst>
+              <a:ext uri="{FF2B5EF4-FFF2-40B4-BE49-F238E27FC236}">
+                <a16:creationId xmlns:a16="http://schemas.microsoft.com/office/drawing/2014/main" id="{29A6D85C-5993-48E6-8DBF-B140F00559A6}"/>
+              </a:ext>
+            </a:extLst>
+          </p:cNvPr>
+          <p:cNvPicPr>
+            <a:picLocks noChangeAspect="1"/>
+          </p:cNvPicPr>
           <p:nvPr/>
-        </p:nvSpPr>
-        <p:spPr>
-          <a:xfrm>
-            <a:off x="6263640" y="1325880"/>
-            <a:ext cx="5212080" cy="4480560"/>
-          </a:xfrm>
-          <a:prstGeom prst="roundRect">
+        </p:nvPicPr>
+        <p:blipFill>
+          <a:blip r:embed="rId2"/>
+          <a:stretch>
+            <a:fillRect/>
+          </a:stretch>
+        </p:blipFill>
+        <p:spPr>
+          <a:xfrm>
+            <a:off x="3943586" y="1109133"/>
+            <a:ext cx="8248414" cy="4639733"/>
+          </a:xfrm>
+          <a:prstGeom prst="rect">
             <a:avLst/>
           </a:prstGeom>
-          <a:solidFill>
-            <a:srgbClr val="FFFFFF"/>
-          </a:solidFill>
-          <a:ln w="15240">
-            <a:solidFill>
-              <a:srgbClr val="C7D5EB"/>
-            </a:solidFill>
-          </a:ln>
-        </p:spPr>
-        <p:style>
-          <a:lnRef idx="1">
-            <a:schemeClr val="accent1"/>
-          </a:lnRef>
-          <a:fillRef idx="3">
-            <a:schemeClr val="accent1"/>
-          </a:fillRef>
-          <a:effectRef idx="2">
-            <a:schemeClr val="accent1"/>
-          </a:effectRef>
-          <a:fontRef idx="minor">
-            <a:schemeClr val="lt1"/>
-          </a:fontRef>
-        </p:style>
-        <p:txBody>
-          <a:bodyPr rtlCol="0" anchor="ctr"/>
-          <a:lstStyle/>
-          <a:p>
-            <a:pPr algn="ctr">
-              <a:defRPr sz="1800" b="1">
-                <a:solidFill>
-                  <a:srgbClr val="607496"/>
-                </a:solidFill>
-              </a:defRPr>
-            </a:pPr>
-            <a:r>
-              <a:t>Скриншот:</a:t>
-            </a:r>
-            <a:br/>
-            <a:r>
-              <a:t>desktop список назначенных рисков</a:t>
-            </a:r>
-          </a:p>
-        </p:txBody>
-      </p:sp>
+        </p:spPr>
+      </p:pic>
     </p:spTree>
   </p:cSld>
   <p:clrMapOvr>
@@ -6508,7 +7014,7 @@
 </file>
 
 <file path=ppt/slides/slide9.xml><?xml version="1.0" encoding="utf-8"?>
-<p:sld xmlns:a="http://schemas.openxmlformats.org/drawingml/2006/main" xmlns:p="http://schemas.openxmlformats.org/presentationml/2006/main" xmlns:r="http://schemas.openxmlformats.org/officeDocument/2006/relationships">
+<p:sld xmlns:a="http://schemas.openxmlformats.org/drawingml/2006/main" xmlns:r="http://schemas.openxmlformats.org/officeDocument/2006/relationships" xmlns:p="http://schemas.openxmlformats.org/presentationml/2006/main">
   <p:cSld>
     <p:bg>
       <p:bgPr>
@@ -6524,7 +7030,14 @@
         <p:cNvGrpSpPr/>
         <p:nvPr/>
       </p:nvGrpSpPr>
-      <p:grpSpPr/>
+      <p:grpSpPr>
+        <a:xfrm>
+          <a:off x="0" y="0"/>
+          <a:ext cx="0" cy="0"/>
+          <a:chOff x="0" y="0"/>
+          <a:chExt cx="0" cy="0"/>
+        </a:xfrm>
+      </p:grpSpPr>
       <p:sp>
         <p:nvSpPr>
           <p:cNvPr id="2" name="TextBox 1"/>
@@ -6548,7 +7061,7 @@
           <a:lstStyle/>
           <a:p>
             <a:pPr>
-              <a:defRPr b="1" sz="2800">
+              <a:defRPr sz="2800" b="1">
                 <a:solidFill>
                   <a:srgbClr val="121F36"/>
                 </a:solidFill>
@@ -6713,68 +7226,36 @@
           </a:p>
         </p:txBody>
       </p:sp>
-      <p:sp>
-        <p:nvSpPr>
-          <p:cNvPr id="6" name="Rounded Rectangle 5"/>
-          <p:cNvSpPr/>
+      <p:pic>
+        <p:nvPicPr>
+          <p:cNvPr id="8" name="Рисунок 7">
+            <a:extLst>
+              <a:ext uri="{FF2B5EF4-FFF2-40B4-BE49-F238E27FC236}">
+                <a16:creationId xmlns:a16="http://schemas.microsoft.com/office/drawing/2014/main" id="{B31D93DD-FE22-4EFF-B350-85AD3417B047}"/>
+              </a:ext>
+            </a:extLst>
+          </p:cNvPr>
+          <p:cNvPicPr>
+            <a:picLocks noChangeAspect="1"/>
+          </p:cNvPicPr>
           <p:nvPr/>
-        </p:nvSpPr>
-        <p:spPr>
-          <a:xfrm>
-            <a:off x="6263640" y="1325880"/>
-            <a:ext cx="5212080" cy="4480560"/>
-          </a:xfrm>
-          <a:prstGeom prst="roundRect">
+        </p:nvPicPr>
+        <p:blipFill>
+          <a:blip r:embed="rId2"/>
+          <a:stretch>
+            <a:fillRect/>
+          </a:stretch>
+        </p:blipFill>
+        <p:spPr>
+          <a:xfrm>
+            <a:off x="6307573" y="1001268"/>
+            <a:ext cx="5884427" cy="4614333"/>
+          </a:xfrm>
+          <a:prstGeom prst="rect">
             <a:avLst/>
           </a:prstGeom>
-          <a:solidFill>
-            <a:srgbClr val="FFFFFF"/>
-          </a:solidFill>
-          <a:ln w="15240">
-            <a:solidFill>
-              <a:srgbClr val="C7D5EB"/>
-            </a:solidFill>
-          </a:ln>
-        </p:spPr>
-        <p:style>
-          <a:lnRef idx="1">
-            <a:schemeClr val="accent1"/>
-          </a:lnRef>
-          <a:fillRef idx="3">
-            <a:schemeClr val="accent1"/>
-          </a:fillRef>
-          <a:effectRef idx="2">
-            <a:schemeClr val="accent1"/>
-          </a:effectRef>
-          <a:fontRef idx="minor">
-            <a:schemeClr val="lt1"/>
-          </a:fontRef>
-        </p:style>
-        <p:txBody>
-          <a:bodyPr rtlCol="0" anchor="ctr"/>
-          <a:lstStyle/>
-          <a:p>
-            <a:pPr algn="ctr">
-              <a:defRPr sz="1800" b="1">
-                <a:solidFill>
-                  <a:srgbClr val="607496"/>
-                </a:solidFill>
-              </a:defRPr>
-            </a:pPr>
-            <a:r>
-              <a:t>Скриншот:</a:t>
-            </a:r>
-            <a:br/>
-            <a:r>
-              <a:t>desktop карточка риска</a:t>
-            </a:r>
-            <a:br/>
-            <a:r>
-              <a:t>и форма оценки</a:t>
-            </a:r>
-          </a:p>
-        </p:txBody>
-      </p:sp>
+        </p:spPr>
+      </p:pic>
     </p:spTree>
   </p:cSld>
   <p:clrMapOvr>

</xml_diff>